<commit_message>
Remove incorrect Alborz no-sales claim from analysis doc and deck
Co-Authored-By: Claude Sonnet 5 <noreply@anthropic.com>
Claude-Session: https://claude.ai/code/session_014kMfh5CkRP5YXMJZm4gfqn
</commit_message>
<xml_diff>
--- a/telavang-sales-analysis.pptx
+++ b/telavang-sales-analysis.pptx
@@ -6208,7 +6208,7 @@
                 <a:ea typeface="Arial" pitchFamily="34" charset="-122"/>
                 <a:cs typeface="Arial" pitchFamily="34" charset="-120"/>
               </a:rPr>
-              <a:t>استان پوشش‌داده‌نشده</a:t>
+              <a:t>استان‌های بدون فروش</a:t>
             </a:r>
             <a:endParaRPr lang="en-US" sz="1500" dirty="0"/>
           </a:p>
@@ -6223,7 +6223,7 @@
         <p:spPr>
           <a:xfrm>
             <a:off x="7680960" y="2423160"/>
-            <a:ext cx="3474720" cy="1005840"/>
+            <a:ext cx="3474720" cy="1188720"/>
           </a:xfrm>
           <a:prstGeom prst="rect">
             <a:avLst/>
@@ -6247,7 +6247,7 @@
                 <a:ea typeface="Arial" pitchFamily="34" charset="-122"/>
                 <a:cs typeface="Arial" pitchFamily="34" charset="-120"/>
               </a:rPr>
-              <a:t>البرز، خراسان جنوبی، خراسان شمالی، سیستان و بلوچستان — هیچ فروشی ثبت نشده است.</a:t>
+              <a:t>خراسان جنوبی، خراسان شمالی، سیستان و بلوچستان — در هیچ محصولی حتی یک فاکتور ثبت نشده است.</a:t>
             </a:r>
             <a:endParaRPr lang="en-US" sz="1250" dirty="0"/>
           </a:p>
@@ -6261,8 +6261,8 @@
         </p:nvSpPr>
         <p:spPr>
           <a:xfrm>
-            <a:off x="7680960" y="3520440"/>
-            <a:ext cx="3474720" cy="1188720"/>
+            <a:off x="7680960" y="3794760"/>
+            <a:ext cx="3474720" cy="1005840"/>
           </a:xfrm>
           <a:prstGeom prst="rect">
             <a:avLst/>
@@ -6274,33 +6274,19 @@
           <a:bodyPr wrap="square" lIns="0" tIns="0" rIns="0" bIns="0" rtlCol="0" anchor="ctr"/>
           <a:lstStyle/>
           <a:p>
-            <a:pPr algn="r" indent="0" marL="0">
-              <a:buNone/>
-            </a:pPr>
-            <a:r>
-              <a:rPr lang="en-US" sz="1300" b="1" dirty="0">
-                <a:solidFill>
-                  <a:srgbClr val="EF7D1F"/>
-                </a:solidFill>
-                <a:latin typeface="Arial" pitchFamily="34" charset="0"/>
-                <a:ea typeface="Arial" pitchFamily="34" charset="-122"/>
-                <a:cs typeface="Arial" pitchFamily="34" charset="-120"/>
-              </a:rPr>
-              <a:t>البرز </a:t>
-            </a:r>
             <a:pPr algn="r" indent="0" marL="0">
               <a:buNone/>
             </a:pPr>
             <a:r>
               <a:rPr lang="en-US" sz="1300" dirty="0">
                 <a:solidFill>
-                  <a:srgbClr val="FFFFFF"/>
+                  <a:srgbClr val="E8DFD2"/>
                 </a:solidFill>
                 <a:latin typeface="Arial" pitchFamily="34" charset="0"/>
                 <a:ea typeface="Arial" pitchFamily="34" charset="-122"/>
                 <a:cs typeface="Arial" pitchFamily="34" charset="-120"/>
               </a:rPr>
-              <a:t>با نزدیکی به تهران و تراکم جمعیتی بالا، بزرگ‌ترین فرصتِ ازدست‌رفته است.</a:t>
+              <a:t>این سه استان جمعیت کمتری دارند و در اولویت پایین‌تری برای توسعه قرار می‌گیرند.</a:t>
             </a:r>
             <a:endParaRPr lang="en-US" sz="1300" dirty="0"/>
           </a:p>
@@ -6913,7 +6899,7 @@
                 <a:ea typeface="Arial" pitchFamily="34" charset="-122"/>
                 <a:cs typeface="Arial" pitchFamily="34" charset="-120"/>
               </a:rPr>
-              <a:t>بازار البرز را فعال کنید</a:t>
+              <a:t>تمرکز درآمدی روی ۳ استان برتر را پایش کنید</a:t>
             </a:r>
             <a:endParaRPr lang="en-US" sz="1400" dirty="0"/>
           </a:p>
@@ -7016,133 +7002,6 @@
         <p:spPr>
           <a:xfrm>
             <a:off x="1097280" y="4169664"/>
-            <a:ext cx="4114800" cy="960120"/>
-          </a:xfrm>
-          <a:prstGeom prst="rect">
-            <a:avLst/>
-          </a:prstGeom>
-          <a:noFill/>
-          <a:ln/>
-        </p:spPr>
-        <p:txBody>
-          <a:bodyPr wrap="square" lIns="0" tIns="0" rIns="0" bIns="0" rtlCol="0" anchor="ctr"/>
-          <a:lstStyle/>
-          <a:p>
-            <a:pPr algn="r" indent="0" marL="0">
-              <a:buNone/>
-            </a:pPr>
-            <a:r>
-              <a:rPr lang="en-US" sz="1400" b="1" dirty="0">
-                <a:solidFill>
-                  <a:srgbClr val="231815"/>
-                </a:solidFill>
-                <a:latin typeface="Arial" pitchFamily="34" charset="0"/>
-                <a:ea typeface="Arial" pitchFamily="34" charset="-122"/>
-                <a:cs typeface="Arial" pitchFamily="34" charset="-120"/>
-              </a:rPr>
-              <a:t>تمرکز درآمدی روی ۳ استان برتر را پایش کنید</a:t>
-            </a:r>
-            <a:endParaRPr lang="en-US" sz="1400" dirty="0"/>
-          </a:p>
-        </p:txBody>
-      </p:sp>
-      <p:sp>
-        <p:nvSpPr>
-          <p:cNvPr id="23" name="Shape 21"/>
-          <p:cNvSpPr/>
-          <p:nvPr/>
-        </p:nvSpPr>
-        <p:spPr>
-          <a:xfrm>
-            <a:off x="6583680" y="4169664"/>
-            <a:ext cx="5166360" cy="960120"/>
-          </a:xfrm>
-          <a:prstGeom prst="roundRect">
-            <a:avLst>
-              <a:gd name="adj" fmla="val 9524"/>
-            </a:avLst>
-          </a:prstGeom>
-          <a:solidFill>
-            <a:srgbClr val="FFFFFF"/>
-          </a:solidFill>
-          <a:ln/>
-          <a:effectLst>
-            <a:outerShdw sx="100000" sy="100000" kx="0" ky="0" algn="bl" rotWithShape="0" blurRad="101600" dist="25400" dir="5400000">
-              <a:srgbClr val="4A3A2E">
-                <a:alpha val="14000"/>
-              </a:srgbClr>
-            </a:outerShdw>
-          </a:effectLst>
-        </p:spPr>
-      </p:sp>
-      <p:sp>
-        <p:nvSpPr>
-          <p:cNvPr id="24" name="Shape 22"/>
-          <p:cNvSpPr/>
-          <p:nvPr/>
-        </p:nvSpPr>
-        <p:spPr>
-          <a:xfrm>
-            <a:off x="10972800" y="4370832"/>
-            <a:ext cx="548640" cy="548640"/>
-          </a:xfrm>
-          <a:prstGeom prst="ellipse">
-            <a:avLst/>
-          </a:prstGeom>
-          <a:solidFill>
-            <a:srgbClr val="EF7D1F"/>
-          </a:solidFill>
-          <a:ln/>
-        </p:spPr>
-      </p:sp>
-      <p:sp>
-        <p:nvSpPr>
-          <p:cNvPr id="25" name="Text 23"/>
-          <p:cNvSpPr txBox="1"/>
-          <p:nvPr/>
-        </p:nvSpPr>
-        <p:spPr>
-          <a:xfrm>
-            <a:off x="10972800" y="4370832"/>
-            <a:ext cx="548640" cy="548640"/>
-          </a:xfrm>
-          <a:prstGeom prst="rect">
-            <a:avLst/>
-          </a:prstGeom>
-          <a:noFill/>
-          <a:ln/>
-        </p:spPr>
-        <p:txBody>
-          <a:bodyPr wrap="square" lIns="0" tIns="0" rIns="0" bIns="0" rtlCol="0" anchor="ctr"/>
-          <a:lstStyle/>
-          <a:p>
-            <a:pPr algn="ctr" indent="0" marL="0">
-              <a:buNone/>
-            </a:pPr>
-            <a:r>
-              <a:rPr lang="en-US" sz="1800" b="1" dirty="0">
-                <a:solidFill>
-                  <a:srgbClr val="FFFFFF"/>
-                </a:solidFill>
-                <a:latin typeface="Arial" pitchFamily="34" charset="0"/>
-                <a:ea typeface="Arial" pitchFamily="34" charset="-122"/>
-                <a:cs typeface="Arial" pitchFamily="34" charset="-120"/>
-              </a:rPr>
-              <a:t>6</a:t>
-            </a:r>
-            <a:endParaRPr lang="en-US" sz="1800" dirty="0"/>
-          </a:p>
-        </p:txBody>
-      </p:sp>
-      <p:sp>
-        <p:nvSpPr>
-          <p:cNvPr id="26" name="Text 24"/>
-          <p:cNvSpPr txBox="1"/>
-          <p:nvPr/>
-        </p:nvSpPr>
-        <p:spPr>
-          <a:xfrm>
-            <a:off x="6812280" y="4169664"/>
             <a:ext cx="4114800" cy="960120"/>
           </a:xfrm>
           <a:prstGeom prst="rect">

</xml_diff>

<commit_message>
Expand sales analysis with forecast accuracy, rep churn/growth, and population-weighted geographic findings
Co-Authored-By: Claude Sonnet 5 <noreply@anthropic.com>
Claude-Session: https://claude.ai/code/session_014kMfh5CkRP5YXMJZm4gfqn
</commit_message>
<xml_diff>
--- a/telavang-sales-analysis.pptx
+++ b/telavang-sales-analysis.pptx
@@ -12,9 +12,10 @@
     <p:sldId id="260" r:id="rId6"/>
     <p:sldId id="261" r:id="rId7"/>
     <p:sldId id="262" r:id="rId8"/>
+    <p:sldId id="263" r:id="rId9"/>
   </p:sldIdLst>
   <p:notesMasterIdLst>
-    <p:notesMasterId r:id="rId9"/>
+    <p:notesMasterId r:id="rId10"/>
   </p:notesMasterIdLst>
   <p:sldSz cx="12192000" cy="6858000"/>
   <p:notesSz cx="6858000" cy="12192000"/>
@@ -1348,6 +1349,94 @@
             <a:fld id="{F7021451-1387-4CA6-816F-3879F97B5CBC}" type="slidenum">
               <a:rPr lang="en-US"/>
               <a:t>7</a:t>
+            </a:fld>
+            <a:endParaRPr lang="en-US"/>
+          </a:p>
+        </p:txBody>
+      </p:sp>
+    </p:spTree>
+    <p:extLst>
+      <p:ext uri="{BB962C8B-B14F-4D97-AF65-F5344CB8AC3E}">
+        <p14:creationId xmlns:p14="http://schemas.microsoft.com/office/powerpoint/2010/main" val="1024086991"/>
+      </p:ext>
+    </p:extLst>
+  </p:cSld>
+  <p:clrMapOvr>
+    <a:masterClrMapping/>
+  </p:clrMapOvr>
+</p:notes>
+</file>
+
+<file path=ppt/notesSlides/notesSlide8.xml><?xml version="1.0" encoding="utf-8"?>
+<p:notes xmlns:a="http://schemas.openxmlformats.org/drawingml/2006/main" xmlns:r="http://schemas.openxmlformats.org/officeDocument/2006/relationships" xmlns:p="http://schemas.openxmlformats.org/presentationml/2006/main">
+  <p:cSld>
+    <p:spTree>
+      <p:nvGrpSpPr>
+        <p:cNvPr id="1" name=""/>
+        <p:cNvGrpSpPr/>
+        <p:nvPr/>
+      </p:nvGrpSpPr>
+      <p:grpSpPr>
+        <a:xfrm>
+          <a:off x="0" y="0"/>
+          <a:ext cx="0" cy="0"/>
+          <a:chOff x="0" y="0"/>
+          <a:chExt cx="0" cy="0"/>
+        </a:xfrm>
+      </p:grpSpPr>
+      <p:sp>
+        <p:nvSpPr>
+          <p:cNvPr id="2" name="Slide Image Placeholder 1"/>
+          <p:cNvSpPr>
+            <a:spLocks noGrp="1" noRot="1" noChangeAspect="1"/>
+          </p:cNvSpPr>
+          <p:nvPr>
+            <p:ph type="sldImg"/>
+          </p:nvPr>
+        </p:nvSpPr>
+        <p:spPr/>
+      </p:sp>
+      <p:sp>
+        <p:nvSpPr>
+          <p:cNvPr id="3" name="Notes Placeholder 2"/>
+          <p:cNvSpPr>
+            <a:spLocks noGrp="1"/>
+          </p:cNvSpPr>
+          <p:nvPr>
+            <p:ph type="body" idx="1"/>
+          </p:nvPr>
+        </p:nvSpPr>
+        <p:spPr/>
+        <p:txBody>
+          <a:bodyPr/>
+          <a:lstStyle/>
+          <a:p>
+            <a:r>
+              <a:rPr lang="en-US" dirty="0"/>
+              <a:t/>
+            </a:r>
+            <a:endParaRPr lang="en-US" dirty="0"/>
+          </a:p>
+        </p:txBody>
+      </p:sp>
+      <p:sp>
+        <p:nvSpPr>
+          <p:cNvPr id="4" name="Slide Number Placeholder 3"/>
+          <p:cNvSpPr>
+            <a:spLocks noGrp="1"/>
+          </p:cNvSpPr>
+          <p:nvPr>
+            <p:ph type="sldNum" sz="quarter" idx="10"/>
+          </p:nvPr>
+        </p:nvSpPr>
+        <p:spPr/>
+        <p:txBody>
+          <a:bodyPr/>
+          <a:lstStyle/>
+          <a:p>
+            <a:fld id="{F7021451-1387-4CA6-816F-3879F97B5CBC}" type="slidenum">
+              <a:rPr lang="en-US"/>
+              <a:t>8</a:t>
             </a:fld>
             <a:endParaRPr lang="en-US"/>
           </a:p>
@@ -2989,6 +3078,59 @@
           </a:graphicData>
         </a:graphic>
       </p:graphicFrame>
+      <p:sp>
+        <p:nvSpPr>
+          <p:cNvPr id="4" name="Text 1"/>
+          <p:cNvSpPr txBox="1"/>
+          <p:nvPr/>
+        </p:nvSpPr>
+        <p:spPr>
+          <a:xfrm>
+            <a:off x="822960" y="6172200"/>
+            <a:ext cx="10515600" cy="548640"/>
+          </a:xfrm>
+          <a:prstGeom prst="rect">
+            <a:avLst/>
+          </a:prstGeom>
+          <a:noFill/>
+          <a:ln/>
+        </p:spPr>
+        <p:txBody>
+          <a:bodyPr wrap="square" lIns="0" tIns="0" rIns="0" bIns="0" rtlCol="0" anchor="ctr"/>
+          <a:lstStyle/>
+          <a:p>
+            <a:pPr algn="r" indent="0" marL="0">
+              <a:buNone/>
+            </a:pPr>
+            <a:r>
+              <a:rPr lang="en-US" sz="1150" b="1" i="1" dirty="0">
+                <a:solidFill>
+                  <a:srgbClr val="4A3A2E"/>
+                </a:solidFill>
+                <a:latin typeface="Arial" pitchFamily="34" charset="0"/>
+                <a:ea typeface="Arial" pitchFamily="34" charset="-122"/>
+                <a:cs typeface="Arial" pitchFamily="34" charset="-120"/>
+              </a:rPr>
+              <a:t>زنجیره‌ای‌ها </a:t>
+            </a:r>
+            <a:pPr algn="r" indent="0" marL="0">
+              <a:buNone/>
+            </a:pPr>
+            <a:r>
+              <a:rPr lang="en-US" sz="1150" i="1" dirty="0">
+                <a:solidFill>
+                  <a:srgbClr val="4A3A2E"/>
+                </a:solidFill>
+                <a:latin typeface="Arial" pitchFamily="34" charset="0"/>
+                <a:ea typeface="Arial" pitchFamily="34" charset="-122"/>
+                <a:cs typeface="Arial" pitchFamily="34" charset="-120"/>
+              </a:rPr>
+              <a:t>(بزرگ‌ترین کانال، خارج از این نمودار) این ماه ۸٫۶٪− افت کرده، اما نسبت به مدت مشابه سال قبل ۶۳٫۴٪+ رشد داشته — افت ماهانه در کنار روند بلندمدت صعودی باید دیده شود.</a:t>
+            </a:r>
+            <a:endParaRPr lang="en-US" sz="1150" dirty="0"/>
+          </a:p>
+        </p:txBody>
+      </p:sp>
     </p:spTree>
   </p:cSld>
   <p:clrMapOvr>
@@ -5107,6 +5249,1063 @@
                 <a:ea typeface="Arial" pitchFamily="34" charset="-122"/>
                 <a:cs typeface="Arial" pitchFamily="34" charset="-120"/>
               </a:rPr>
+              <a:t>دقت پیش‌بینی و پویایی نمایندگان</a:t>
+            </a:r>
+            <a:endParaRPr lang="en-US" sz="3000" dirty="0"/>
+          </a:p>
+        </p:txBody>
+      </p:sp>
+      <p:sp>
+        <p:nvSpPr>
+          <p:cNvPr id="3" name="Shape 1"/>
+          <p:cNvSpPr/>
+          <p:nvPr/>
+        </p:nvSpPr>
+        <p:spPr>
+          <a:xfrm>
+            <a:off x="822960" y="1691640"/>
+            <a:ext cx="5074920" cy="3886200"/>
+          </a:xfrm>
+          <a:prstGeom prst="roundRect">
+            <a:avLst>
+              <a:gd name="adj" fmla="val 2824"/>
+            </a:avLst>
+          </a:prstGeom>
+          <a:solidFill>
+            <a:srgbClr val="FFFFFF"/>
+          </a:solidFill>
+          <a:ln/>
+          <a:effectLst>
+            <a:outerShdw sx="100000" sy="100000" kx="0" ky="0" algn="bl" rotWithShape="0" blurRad="127000" dist="38100" dir="5400000">
+              <a:srgbClr val="4A3A2E">
+                <a:alpha val="16000"/>
+              </a:srgbClr>
+            </a:outerShdw>
+          </a:effectLst>
+        </p:spPr>
+      </p:sp>
+      <p:sp>
+        <p:nvSpPr>
+          <p:cNvPr id="4" name="Text 2"/>
+          <p:cNvSpPr txBox="1"/>
+          <p:nvPr/>
+        </p:nvSpPr>
+        <p:spPr>
+          <a:xfrm>
+            <a:off x="1097280" y="1920240"/>
+            <a:ext cx="4526280" cy="457200"/>
+          </a:xfrm>
+          <a:prstGeom prst="rect">
+            <a:avLst/>
+          </a:prstGeom>
+          <a:noFill/>
+          <a:ln/>
+        </p:spPr>
+        <p:txBody>
+          <a:bodyPr wrap="square" lIns="0" tIns="0" rIns="0" bIns="0" rtlCol="0" anchor="ctr"/>
+          <a:lstStyle/>
+          <a:p>
+            <a:pPr algn="r" indent="0" marL="0">
+              <a:buNone/>
+            </a:pPr>
+            <a:r>
+              <a:rPr lang="en-US" sz="1600" b="1" dirty="0">
+                <a:solidFill>
+                  <a:srgbClr val="231815"/>
+                </a:solidFill>
+                <a:latin typeface="Arial" pitchFamily="34" charset="0"/>
+                <a:ea typeface="Arial" pitchFamily="34" charset="-122"/>
+                <a:cs typeface="Arial" pitchFamily="34" charset="-120"/>
+              </a:rPr>
+              <a:t>موتور پیش‌بینی قابل‌اعتماد است</a:t>
+            </a:r>
+            <a:endParaRPr lang="en-US" sz="1600" dirty="0"/>
+          </a:p>
+        </p:txBody>
+      </p:sp>
+      <p:graphicFrame>
+        <p:nvGraphicFramePr>
+          <p:cNvPr id="7" name="Table 0"/>
+          <p:cNvGraphicFramePr>
+            <a:graphicFrameLocks noGrp="1"/>
+          </p:cNvGraphicFramePr>
+          <p:nvPr>
+            <p:extLst>
+              <p:ext uri="{D42A27DB-BD31-4B8C-83A1-F6EECF244321}">
+                <p14:modId xmlns:p14="http://schemas.microsoft.com/office/powerpoint/2010/main" val="1579011935"/>
+              </p:ext>
+            </p:extLst>
+          </p:nvPr>
+        </p:nvGraphicFramePr>
+        <p:xfrm>
+          <a:off x="1097280" y="2514600"/>
+          <a:ext cx="4526280" cy="1828800"/>
+        </p:xfrm>
+        <a:graphic>
+          <a:graphicData uri="http://schemas.openxmlformats.org/drawingml/2006/table">
+            <a:tbl>
+              <a:tblPr/>
+              <a:tblGrid>
+                <a:gridCol w="2263140"/>
+                <a:gridCol w="2263140"/>
+              </a:tblGrid>
+              <a:tr h="365760">
+                <a:tc>
+                  <a:txBody>
+                    <a:bodyPr/>
+                    <a:lstStyle/>
+                    <a:p>
+                      <a:pPr algn="ctr" indent="0" marL="0">
+                        <a:buNone/>
+                      </a:pPr>
+                      <a:r>
+                        <a:rPr lang="en-US" sz="1300" b="1" dirty="0">
+                          <a:solidFill>
+                            <a:srgbClr val="FFFFFF"/>
+                          </a:solidFill>
+                        </a:rPr>
+                        <a:t>محصول</a:t>
+                      </a:r>
+                      <a:endParaRPr lang="en-US" sz="1300" dirty="0"/>
+                    </a:p>
+                  </a:txBody>
+                  <a:tcPr marL="91440" marR="91440" marT="45720" marB="45720">
+                    <a:lnL w="6350" cap="flat" cmpd="sng" algn="ctr">
+                      <a:solidFill>
+                        <a:srgbClr val="DDD7CD"/>
+                      </a:solidFill>
+                      <a:prstDash val="solid"/>
+                      <a:round/>
+                      <a:headEnd type="none" w="med" len="med"/>
+                      <a:tailEnd type="none" w="med" len="med"/>
+                    </a:lnL>
+                    <a:lnR w="6350" cap="flat" cmpd="sng" algn="ctr">
+                      <a:solidFill>
+                        <a:srgbClr val="DDD7CD"/>
+                      </a:solidFill>
+                      <a:prstDash val="solid"/>
+                      <a:round/>
+                      <a:headEnd type="none" w="med" len="med"/>
+                      <a:tailEnd type="none" w="med" len="med"/>
+                    </a:lnR>
+                    <a:lnT w="6350" cap="flat" cmpd="sng" algn="ctr">
+                      <a:solidFill>
+                        <a:srgbClr val="DDD7CD"/>
+                      </a:solidFill>
+                      <a:prstDash val="solid"/>
+                      <a:round/>
+                      <a:headEnd type="none" w="med" len="med"/>
+                      <a:tailEnd type="none" w="med" len="med"/>
+                    </a:lnT>
+                    <a:lnB w="6350" cap="flat" cmpd="sng" algn="ctr">
+                      <a:solidFill>
+                        <a:srgbClr val="DDD7CD"/>
+                      </a:solidFill>
+                      <a:prstDash val="solid"/>
+                      <a:round/>
+                      <a:headEnd type="none" w="med" len="med"/>
+                      <a:tailEnd type="none" w="med" len="med"/>
+                    </a:lnB>
+                    <a:solidFill>
+                      <a:srgbClr val="1E2761"/>
+                    </a:solidFill>
+                  </a:tcPr>
+                </a:tc>
+                <a:tc>
+                  <a:txBody>
+                    <a:bodyPr/>
+                    <a:lstStyle/>
+                    <a:p>
+                      <a:pPr algn="ctr" indent="0" marL="0">
+                        <a:buNone/>
+                      </a:pPr>
+                      <a:r>
+                        <a:rPr lang="en-US" sz="1300" b="1" dirty="0">
+                          <a:solidFill>
+                            <a:srgbClr val="FFFFFF"/>
+                          </a:solidFill>
+                        </a:rPr>
+                        <a:t>خطا (WAPE)</a:t>
+                      </a:r>
+                      <a:endParaRPr lang="en-US" sz="1300" dirty="0"/>
+                    </a:p>
+                  </a:txBody>
+                  <a:tcPr marL="91440" marR="91440" marT="45720" marB="45720">
+                    <a:lnL w="6350" cap="flat" cmpd="sng" algn="ctr">
+                      <a:solidFill>
+                        <a:srgbClr val="DDD7CD"/>
+                      </a:solidFill>
+                      <a:prstDash val="solid"/>
+                      <a:round/>
+                      <a:headEnd type="none" w="med" len="med"/>
+                      <a:tailEnd type="none" w="med" len="med"/>
+                    </a:lnL>
+                    <a:lnR w="6350" cap="flat" cmpd="sng" algn="ctr">
+                      <a:solidFill>
+                        <a:srgbClr val="DDD7CD"/>
+                      </a:solidFill>
+                      <a:prstDash val="solid"/>
+                      <a:round/>
+                      <a:headEnd type="none" w="med" len="med"/>
+                      <a:tailEnd type="none" w="med" len="med"/>
+                    </a:lnR>
+                    <a:lnT w="6350" cap="flat" cmpd="sng" algn="ctr">
+                      <a:solidFill>
+                        <a:srgbClr val="DDD7CD"/>
+                      </a:solidFill>
+                      <a:prstDash val="solid"/>
+                      <a:round/>
+                      <a:headEnd type="none" w="med" len="med"/>
+                      <a:tailEnd type="none" w="med" len="med"/>
+                    </a:lnT>
+                    <a:lnB w="6350" cap="flat" cmpd="sng" algn="ctr">
+                      <a:solidFill>
+                        <a:srgbClr val="DDD7CD"/>
+                      </a:solidFill>
+                      <a:prstDash val="solid"/>
+                      <a:round/>
+                      <a:headEnd type="none" w="med" len="med"/>
+                      <a:tailEnd type="none" w="med" len="med"/>
+                    </a:lnB>
+                    <a:solidFill>
+                      <a:srgbClr val="1E2761"/>
+                    </a:solidFill>
+                  </a:tcPr>
+                </a:tc>
+              </a:tr>
+              <a:tr h="365760">
+                <a:tc>
+                  <a:txBody>
+                    <a:bodyPr/>
+                    <a:lstStyle/>
+                    <a:p>
+                      <a:pPr algn="ctr" indent="0" marL="0">
+                        <a:buNone/>
+                      </a:pPr>
+                      <a:r>
+                        <a:rPr lang="en-US" sz="1300" b="1" dirty="0">
+                          <a:solidFill>
+                            <a:srgbClr val="231815"/>
+                          </a:solidFill>
+                          <a:latin typeface="Arial" pitchFamily="34" charset="0"/>
+                          <a:ea typeface="Arial" pitchFamily="34" charset="-122"/>
+                          <a:cs typeface="Arial" pitchFamily="34" charset="-120"/>
+                        </a:rPr>
+                        <a:t>تخم‌مرغ</a:t>
+                      </a:r>
+                      <a:endParaRPr lang="en-US" sz="1300" dirty="0">
+                        <a:latin typeface="Arial" charset="0"/>
+                        <a:ea typeface="Arial" charset="0"/>
+                        <a:cs typeface="Arial" charset="0"/>
+                      </a:endParaRPr>
+                    </a:p>
+                  </a:txBody>
+                  <a:tcPr marL="91440" marR="91440" marT="45720" marB="45720">
+                    <a:lnL w="6350" cap="flat" cmpd="sng" algn="ctr">
+                      <a:solidFill>
+                        <a:srgbClr val="DDD7CD"/>
+                      </a:solidFill>
+                      <a:prstDash val="solid"/>
+                      <a:round/>
+                      <a:headEnd type="none" w="med" len="med"/>
+                      <a:tailEnd type="none" w="med" len="med"/>
+                    </a:lnL>
+                    <a:lnR w="6350" cap="flat" cmpd="sng" algn="ctr">
+                      <a:solidFill>
+                        <a:srgbClr val="DDD7CD"/>
+                      </a:solidFill>
+                      <a:prstDash val="solid"/>
+                      <a:round/>
+                      <a:headEnd type="none" w="med" len="med"/>
+                      <a:tailEnd type="none" w="med" len="med"/>
+                    </a:lnR>
+                    <a:lnT w="6350" cap="flat" cmpd="sng" algn="ctr">
+                      <a:solidFill>
+                        <a:srgbClr val="DDD7CD"/>
+                      </a:solidFill>
+                      <a:prstDash val="solid"/>
+                      <a:round/>
+                      <a:headEnd type="none" w="med" len="med"/>
+                      <a:tailEnd type="none" w="med" len="med"/>
+                    </a:lnT>
+                    <a:lnB w="6350" cap="flat" cmpd="sng" algn="ctr">
+                      <a:solidFill>
+                        <a:srgbClr val="DDD7CD"/>
+                      </a:solidFill>
+                      <a:prstDash val="solid"/>
+                      <a:round/>
+                      <a:headEnd type="none" w="med" len="med"/>
+                      <a:tailEnd type="none" w="med" len="med"/>
+                    </a:lnB>
+                    <a:solidFill>
+                      <a:srgbClr val="EFEAE1"/>
+                    </a:solidFill>
+                  </a:tcPr>
+                </a:tc>
+                <a:tc>
+                  <a:txBody>
+                    <a:bodyPr/>
+                    <a:lstStyle/>
+                    <a:p>
+                      <a:pPr algn="ctr" indent="0" marL="0">
+                        <a:buNone/>
+                      </a:pPr>
+                      <a:r>
+                        <a:rPr lang="en-US" sz="1300" dirty="0">
+                          <a:solidFill>
+                            <a:srgbClr val="231815"/>
+                          </a:solidFill>
+                          <a:latin typeface="Arial" pitchFamily="34" charset="0"/>
+                          <a:ea typeface="Arial" pitchFamily="34" charset="-122"/>
+                          <a:cs typeface="Arial" pitchFamily="34" charset="-120"/>
+                        </a:rPr>
+                        <a:t>۷٫۶٪</a:t>
+                      </a:r>
+                      <a:endParaRPr lang="en-US" sz="1300" dirty="0">
+                        <a:latin typeface="Arial" charset="0"/>
+                        <a:ea typeface="Arial" charset="0"/>
+                        <a:cs typeface="Arial" charset="0"/>
+                      </a:endParaRPr>
+                    </a:p>
+                  </a:txBody>
+                  <a:tcPr marL="91440" marR="91440" marT="45720" marB="45720">
+                    <a:lnL w="6350" cap="flat" cmpd="sng" algn="ctr">
+                      <a:solidFill>
+                        <a:srgbClr val="DDD7CD"/>
+                      </a:solidFill>
+                      <a:prstDash val="solid"/>
+                      <a:round/>
+                      <a:headEnd type="none" w="med" len="med"/>
+                      <a:tailEnd type="none" w="med" len="med"/>
+                    </a:lnL>
+                    <a:lnR w="6350" cap="flat" cmpd="sng" algn="ctr">
+                      <a:solidFill>
+                        <a:srgbClr val="DDD7CD"/>
+                      </a:solidFill>
+                      <a:prstDash val="solid"/>
+                      <a:round/>
+                      <a:headEnd type="none" w="med" len="med"/>
+                      <a:tailEnd type="none" w="med" len="med"/>
+                    </a:lnR>
+                    <a:lnT w="6350" cap="flat" cmpd="sng" algn="ctr">
+                      <a:solidFill>
+                        <a:srgbClr val="DDD7CD"/>
+                      </a:solidFill>
+                      <a:prstDash val="solid"/>
+                      <a:round/>
+                      <a:headEnd type="none" w="med" len="med"/>
+                      <a:tailEnd type="none" w="med" len="med"/>
+                    </a:lnT>
+                    <a:lnB w="6350" cap="flat" cmpd="sng" algn="ctr">
+                      <a:solidFill>
+                        <a:srgbClr val="DDD7CD"/>
+                      </a:solidFill>
+                      <a:prstDash val="solid"/>
+                      <a:round/>
+                      <a:headEnd type="none" w="med" len="med"/>
+                      <a:tailEnd type="none" w="med" len="med"/>
+                    </a:lnB>
+                    <a:solidFill>
+                      <a:srgbClr val="EFEAE1"/>
+                    </a:solidFill>
+                  </a:tcPr>
+                </a:tc>
+              </a:tr>
+              <a:tr h="365760">
+                <a:tc>
+                  <a:txBody>
+                    <a:bodyPr/>
+                    <a:lstStyle/>
+                    <a:p>
+                      <a:pPr algn="ctr" indent="0" marL="0">
+                        <a:buNone/>
+                      </a:pPr>
+                      <a:r>
+                        <a:rPr lang="en-US" sz="1300" b="1" dirty="0">
+                          <a:solidFill>
+                            <a:srgbClr val="231815"/>
+                          </a:solidFill>
+                          <a:latin typeface="Arial" pitchFamily="34" charset="0"/>
+                          <a:ea typeface="Arial" pitchFamily="34" charset="-122"/>
+                          <a:cs typeface="Arial" pitchFamily="34" charset="-120"/>
+                        </a:rPr>
+                        <a:t>تخم ماکیان</a:t>
+                      </a:r>
+                      <a:endParaRPr lang="en-US" sz="1300" dirty="0">
+                        <a:latin typeface="Arial" charset="0"/>
+                        <a:ea typeface="Arial" charset="0"/>
+                        <a:cs typeface="Arial" charset="0"/>
+                      </a:endParaRPr>
+                    </a:p>
+                  </a:txBody>
+                  <a:tcPr marL="91440" marR="91440" marT="45720" marB="45720">
+                    <a:lnL w="6350" cap="flat" cmpd="sng" algn="ctr">
+                      <a:solidFill>
+                        <a:srgbClr val="DDD7CD"/>
+                      </a:solidFill>
+                      <a:prstDash val="solid"/>
+                      <a:round/>
+                      <a:headEnd type="none" w="med" len="med"/>
+                      <a:tailEnd type="none" w="med" len="med"/>
+                    </a:lnL>
+                    <a:lnR w="6350" cap="flat" cmpd="sng" algn="ctr">
+                      <a:solidFill>
+                        <a:srgbClr val="DDD7CD"/>
+                      </a:solidFill>
+                      <a:prstDash val="solid"/>
+                      <a:round/>
+                      <a:headEnd type="none" w="med" len="med"/>
+                      <a:tailEnd type="none" w="med" len="med"/>
+                    </a:lnR>
+                    <a:lnT w="6350" cap="flat" cmpd="sng" algn="ctr">
+                      <a:solidFill>
+                        <a:srgbClr val="DDD7CD"/>
+                      </a:solidFill>
+                      <a:prstDash val="solid"/>
+                      <a:round/>
+                      <a:headEnd type="none" w="med" len="med"/>
+                      <a:tailEnd type="none" w="med" len="med"/>
+                    </a:lnT>
+                    <a:lnB w="6350" cap="flat" cmpd="sng" algn="ctr">
+                      <a:solidFill>
+                        <a:srgbClr val="DDD7CD"/>
+                      </a:solidFill>
+                      <a:prstDash val="solid"/>
+                      <a:round/>
+                      <a:headEnd type="none" w="med" len="med"/>
+                      <a:tailEnd type="none" w="med" len="med"/>
+                    </a:lnB>
+                    <a:solidFill>
+                      <a:srgbClr val="FFFFFF"/>
+                    </a:solidFill>
+                  </a:tcPr>
+                </a:tc>
+                <a:tc>
+                  <a:txBody>
+                    <a:bodyPr/>
+                    <a:lstStyle/>
+                    <a:p>
+                      <a:pPr algn="ctr" indent="0" marL="0">
+                        <a:buNone/>
+                      </a:pPr>
+                      <a:r>
+                        <a:rPr lang="en-US" sz="1300" dirty="0">
+                          <a:solidFill>
+                            <a:srgbClr val="231815"/>
+                          </a:solidFill>
+                          <a:latin typeface="Arial" pitchFamily="34" charset="0"/>
+                          <a:ea typeface="Arial" pitchFamily="34" charset="-122"/>
+                          <a:cs typeface="Arial" pitchFamily="34" charset="-120"/>
+                        </a:rPr>
+                        <a:t>۹٫۲٪</a:t>
+                      </a:r>
+                      <a:endParaRPr lang="en-US" sz="1300" dirty="0">
+                        <a:latin typeface="Arial" charset="0"/>
+                        <a:ea typeface="Arial" charset="0"/>
+                        <a:cs typeface="Arial" charset="0"/>
+                      </a:endParaRPr>
+                    </a:p>
+                  </a:txBody>
+                  <a:tcPr marL="91440" marR="91440" marT="45720" marB="45720">
+                    <a:lnL w="6350" cap="flat" cmpd="sng" algn="ctr">
+                      <a:solidFill>
+                        <a:srgbClr val="DDD7CD"/>
+                      </a:solidFill>
+                      <a:prstDash val="solid"/>
+                      <a:round/>
+                      <a:headEnd type="none" w="med" len="med"/>
+                      <a:tailEnd type="none" w="med" len="med"/>
+                    </a:lnL>
+                    <a:lnR w="6350" cap="flat" cmpd="sng" algn="ctr">
+                      <a:solidFill>
+                        <a:srgbClr val="DDD7CD"/>
+                      </a:solidFill>
+                      <a:prstDash val="solid"/>
+                      <a:round/>
+                      <a:headEnd type="none" w="med" len="med"/>
+                      <a:tailEnd type="none" w="med" len="med"/>
+                    </a:lnR>
+                    <a:lnT w="6350" cap="flat" cmpd="sng" algn="ctr">
+                      <a:solidFill>
+                        <a:srgbClr val="DDD7CD"/>
+                      </a:solidFill>
+                      <a:prstDash val="solid"/>
+                      <a:round/>
+                      <a:headEnd type="none" w="med" len="med"/>
+                      <a:tailEnd type="none" w="med" len="med"/>
+                    </a:lnT>
+                    <a:lnB w="6350" cap="flat" cmpd="sng" algn="ctr">
+                      <a:solidFill>
+                        <a:srgbClr val="DDD7CD"/>
+                      </a:solidFill>
+                      <a:prstDash val="solid"/>
+                      <a:round/>
+                      <a:headEnd type="none" w="med" len="med"/>
+                      <a:tailEnd type="none" w="med" len="med"/>
+                    </a:lnB>
+                    <a:solidFill>
+                      <a:srgbClr val="FFFFFF"/>
+                    </a:solidFill>
+                  </a:tcPr>
+                </a:tc>
+              </a:tr>
+              <a:tr h="365760">
+                <a:tc>
+                  <a:txBody>
+                    <a:bodyPr/>
+                    <a:lstStyle/>
+                    <a:p>
+                      <a:pPr algn="ctr" indent="0" marL="0">
+                        <a:buNone/>
+                      </a:pPr>
+                      <a:r>
+                        <a:rPr lang="en-US" sz="1300" b="1" dirty="0">
+                          <a:solidFill>
+                            <a:srgbClr val="231815"/>
+                          </a:solidFill>
+                          <a:latin typeface="Arial" pitchFamily="34" charset="0"/>
+                          <a:ea typeface="Arial" pitchFamily="34" charset="-122"/>
+                          <a:cs typeface="Arial" pitchFamily="34" charset="-120"/>
+                        </a:rPr>
+                        <a:t>تلابار</a:t>
+                      </a:r>
+                      <a:endParaRPr lang="en-US" sz="1300" dirty="0">
+                        <a:latin typeface="Arial" charset="0"/>
+                        <a:ea typeface="Arial" charset="0"/>
+                        <a:cs typeface="Arial" charset="0"/>
+                      </a:endParaRPr>
+                    </a:p>
+                  </a:txBody>
+                  <a:tcPr marL="91440" marR="91440" marT="45720" marB="45720">
+                    <a:lnL w="6350" cap="flat" cmpd="sng" algn="ctr">
+                      <a:solidFill>
+                        <a:srgbClr val="DDD7CD"/>
+                      </a:solidFill>
+                      <a:prstDash val="solid"/>
+                      <a:round/>
+                      <a:headEnd type="none" w="med" len="med"/>
+                      <a:tailEnd type="none" w="med" len="med"/>
+                    </a:lnL>
+                    <a:lnR w="6350" cap="flat" cmpd="sng" algn="ctr">
+                      <a:solidFill>
+                        <a:srgbClr val="DDD7CD"/>
+                      </a:solidFill>
+                      <a:prstDash val="solid"/>
+                      <a:round/>
+                      <a:headEnd type="none" w="med" len="med"/>
+                      <a:tailEnd type="none" w="med" len="med"/>
+                    </a:lnR>
+                    <a:lnT w="6350" cap="flat" cmpd="sng" algn="ctr">
+                      <a:solidFill>
+                        <a:srgbClr val="DDD7CD"/>
+                      </a:solidFill>
+                      <a:prstDash val="solid"/>
+                      <a:round/>
+                      <a:headEnd type="none" w="med" len="med"/>
+                      <a:tailEnd type="none" w="med" len="med"/>
+                    </a:lnT>
+                    <a:lnB w="6350" cap="flat" cmpd="sng" algn="ctr">
+                      <a:solidFill>
+                        <a:srgbClr val="DDD7CD"/>
+                      </a:solidFill>
+                      <a:prstDash val="solid"/>
+                      <a:round/>
+                      <a:headEnd type="none" w="med" len="med"/>
+                      <a:tailEnd type="none" w="med" len="med"/>
+                    </a:lnB>
+                    <a:solidFill>
+                      <a:srgbClr val="EFEAE1"/>
+                    </a:solidFill>
+                  </a:tcPr>
+                </a:tc>
+                <a:tc>
+                  <a:txBody>
+                    <a:bodyPr/>
+                    <a:lstStyle/>
+                    <a:p>
+                      <a:pPr algn="ctr" indent="0" marL="0">
+                        <a:buNone/>
+                      </a:pPr>
+                      <a:r>
+                        <a:rPr lang="en-US" sz="1300" dirty="0">
+                          <a:solidFill>
+                            <a:srgbClr val="231815"/>
+                          </a:solidFill>
+                          <a:latin typeface="Arial" pitchFamily="34" charset="0"/>
+                          <a:ea typeface="Arial" pitchFamily="34" charset="-122"/>
+                          <a:cs typeface="Arial" pitchFamily="34" charset="-120"/>
+                        </a:rPr>
+                        <a:t>۱۱٫۹٪</a:t>
+                      </a:r>
+                      <a:endParaRPr lang="en-US" sz="1300" dirty="0">
+                        <a:latin typeface="Arial" charset="0"/>
+                        <a:ea typeface="Arial" charset="0"/>
+                        <a:cs typeface="Arial" charset="0"/>
+                      </a:endParaRPr>
+                    </a:p>
+                  </a:txBody>
+                  <a:tcPr marL="91440" marR="91440" marT="45720" marB="45720">
+                    <a:lnL w="6350" cap="flat" cmpd="sng" algn="ctr">
+                      <a:solidFill>
+                        <a:srgbClr val="DDD7CD"/>
+                      </a:solidFill>
+                      <a:prstDash val="solid"/>
+                      <a:round/>
+                      <a:headEnd type="none" w="med" len="med"/>
+                      <a:tailEnd type="none" w="med" len="med"/>
+                    </a:lnL>
+                    <a:lnR w="6350" cap="flat" cmpd="sng" algn="ctr">
+                      <a:solidFill>
+                        <a:srgbClr val="DDD7CD"/>
+                      </a:solidFill>
+                      <a:prstDash val="solid"/>
+                      <a:round/>
+                      <a:headEnd type="none" w="med" len="med"/>
+                      <a:tailEnd type="none" w="med" len="med"/>
+                    </a:lnR>
+                    <a:lnT w="6350" cap="flat" cmpd="sng" algn="ctr">
+                      <a:solidFill>
+                        <a:srgbClr val="DDD7CD"/>
+                      </a:solidFill>
+                      <a:prstDash val="solid"/>
+                      <a:round/>
+                      <a:headEnd type="none" w="med" len="med"/>
+                      <a:tailEnd type="none" w="med" len="med"/>
+                    </a:lnT>
+                    <a:lnB w="6350" cap="flat" cmpd="sng" algn="ctr">
+                      <a:solidFill>
+                        <a:srgbClr val="DDD7CD"/>
+                      </a:solidFill>
+                      <a:prstDash val="solid"/>
+                      <a:round/>
+                      <a:headEnd type="none" w="med" len="med"/>
+                      <a:tailEnd type="none" w="med" len="med"/>
+                    </a:lnB>
+                    <a:solidFill>
+                      <a:srgbClr val="EFEAE1"/>
+                    </a:solidFill>
+                  </a:tcPr>
+                </a:tc>
+              </a:tr>
+              <a:tr h="365760">
+                <a:tc>
+                  <a:txBody>
+                    <a:bodyPr/>
+                    <a:lstStyle/>
+                    <a:p>
+                      <a:pPr algn="ctr" indent="0" marL="0">
+                        <a:buNone/>
+                      </a:pPr>
+                      <a:r>
+                        <a:rPr lang="en-US" sz="1300" b="1" dirty="0">
+                          <a:solidFill>
+                            <a:srgbClr val="231815"/>
+                          </a:solidFill>
+                          <a:latin typeface="Arial" pitchFamily="34" charset="0"/>
+                          <a:ea typeface="Arial" pitchFamily="34" charset="-122"/>
+                          <a:cs typeface="Arial" pitchFamily="34" charset="-120"/>
+                        </a:rPr>
+                        <a:t>زنجیره‌ای‌ها</a:t>
+                      </a:r>
+                      <a:endParaRPr lang="en-US" sz="1300" dirty="0">
+                        <a:latin typeface="Arial" charset="0"/>
+                        <a:ea typeface="Arial" charset="0"/>
+                        <a:cs typeface="Arial" charset="0"/>
+                      </a:endParaRPr>
+                    </a:p>
+                  </a:txBody>
+                  <a:tcPr marL="91440" marR="91440" marT="45720" marB="45720">
+                    <a:lnL w="6350" cap="flat" cmpd="sng" algn="ctr">
+                      <a:solidFill>
+                        <a:srgbClr val="DDD7CD"/>
+                      </a:solidFill>
+                      <a:prstDash val="solid"/>
+                      <a:round/>
+                      <a:headEnd type="none" w="med" len="med"/>
+                      <a:tailEnd type="none" w="med" len="med"/>
+                    </a:lnL>
+                    <a:lnR w="6350" cap="flat" cmpd="sng" algn="ctr">
+                      <a:solidFill>
+                        <a:srgbClr val="DDD7CD"/>
+                      </a:solidFill>
+                      <a:prstDash val="solid"/>
+                      <a:round/>
+                      <a:headEnd type="none" w="med" len="med"/>
+                      <a:tailEnd type="none" w="med" len="med"/>
+                    </a:lnR>
+                    <a:lnT w="6350" cap="flat" cmpd="sng" algn="ctr">
+                      <a:solidFill>
+                        <a:srgbClr val="DDD7CD"/>
+                      </a:solidFill>
+                      <a:prstDash val="solid"/>
+                      <a:round/>
+                      <a:headEnd type="none" w="med" len="med"/>
+                      <a:tailEnd type="none" w="med" len="med"/>
+                    </a:lnT>
+                    <a:lnB w="6350" cap="flat" cmpd="sng" algn="ctr">
+                      <a:solidFill>
+                        <a:srgbClr val="DDD7CD"/>
+                      </a:solidFill>
+                      <a:prstDash val="solid"/>
+                      <a:round/>
+                      <a:headEnd type="none" w="med" len="med"/>
+                      <a:tailEnd type="none" w="med" len="med"/>
+                    </a:lnB>
+                    <a:solidFill>
+                      <a:srgbClr val="FFFFFF"/>
+                    </a:solidFill>
+                  </a:tcPr>
+                </a:tc>
+                <a:tc>
+                  <a:txBody>
+                    <a:bodyPr/>
+                    <a:lstStyle/>
+                    <a:p>
+                      <a:pPr algn="ctr" indent="0" marL="0">
+                        <a:buNone/>
+                      </a:pPr>
+                      <a:r>
+                        <a:rPr lang="en-US" sz="1300" dirty="0">
+                          <a:solidFill>
+                            <a:srgbClr val="231815"/>
+                          </a:solidFill>
+                          <a:latin typeface="Arial" pitchFamily="34" charset="0"/>
+                          <a:ea typeface="Arial" pitchFamily="34" charset="-122"/>
+                          <a:cs typeface="Arial" pitchFamily="34" charset="-120"/>
+                        </a:rPr>
+                        <a:t>۱۲٫۷٪</a:t>
+                      </a:r>
+                      <a:endParaRPr lang="en-US" sz="1300" dirty="0">
+                        <a:latin typeface="Arial" charset="0"/>
+                        <a:ea typeface="Arial" charset="0"/>
+                        <a:cs typeface="Arial" charset="0"/>
+                      </a:endParaRPr>
+                    </a:p>
+                  </a:txBody>
+                  <a:tcPr marL="91440" marR="91440" marT="45720" marB="45720">
+                    <a:lnL w="6350" cap="flat" cmpd="sng" algn="ctr">
+                      <a:solidFill>
+                        <a:srgbClr val="DDD7CD"/>
+                      </a:solidFill>
+                      <a:prstDash val="solid"/>
+                      <a:round/>
+                      <a:headEnd type="none" w="med" len="med"/>
+                      <a:tailEnd type="none" w="med" len="med"/>
+                    </a:lnL>
+                    <a:lnR w="6350" cap="flat" cmpd="sng" algn="ctr">
+                      <a:solidFill>
+                        <a:srgbClr val="DDD7CD"/>
+                      </a:solidFill>
+                      <a:prstDash val="solid"/>
+                      <a:round/>
+                      <a:headEnd type="none" w="med" len="med"/>
+                      <a:tailEnd type="none" w="med" len="med"/>
+                    </a:lnR>
+                    <a:lnT w="6350" cap="flat" cmpd="sng" algn="ctr">
+                      <a:solidFill>
+                        <a:srgbClr val="DDD7CD"/>
+                      </a:solidFill>
+                      <a:prstDash val="solid"/>
+                      <a:round/>
+                      <a:headEnd type="none" w="med" len="med"/>
+                      <a:tailEnd type="none" w="med" len="med"/>
+                    </a:lnT>
+                    <a:lnB w="6350" cap="flat" cmpd="sng" algn="ctr">
+                      <a:solidFill>
+                        <a:srgbClr val="DDD7CD"/>
+                      </a:solidFill>
+                      <a:prstDash val="solid"/>
+                      <a:round/>
+                      <a:headEnd type="none" w="med" len="med"/>
+                      <a:tailEnd type="none" w="med" len="med"/>
+                    </a:lnB>
+                    <a:solidFill>
+                      <a:srgbClr val="FFFFFF"/>
+                    </a:solidFill>
+                  </a:tcPr>
+                </a:tc>
+              </a:tr>
+            </a:tbl>
+          </a:graphicData>
+        </a:graphic>
+      </p:graphicFrame>
+      <p:sp>
+        <p:nvSpPr>
+          <p:cNvPr id="6" name="Text 3"/>
+          <p:cNvSpPr txBox="1"/>
+          <p:nvPr/>
+        </p:nvSpPr>
+        <p:spPr>
+          <a:xfrm>
+            <a:off x="1097280" y="4526280"/>
+            <a:ext cx="4526280" cy="822960"/>
+          </a:xfrm>
+          <a:prstGeom prst="rect">
+            <a:avLst/>
+          </a:prstGeom>
+          <a:noFill/>
+          <a:ln/>
+        </p:spPr>
+        <p:txBody>
+          <a:bodyPr wrap="square" lIns="0" tIns="0" rIns="0" bIns="0" rtlCol="0" anchor="ctr"/>
+          <a:lstStyle/>
+          <a:p>
+            <a:pPr algn="r" indent="0" marL="0">
+              <a:buNone/>
+            </a:pPr>
+            <a:r>
+              <a:rPr lang="en-US" sz="1250" i="1" dirty="0">
+                <a:solidFill>
+                  <a:srgbClr val="4A3A2E"/>
+                </a:solidFill>
+                <a:latin typeface="Arial" pitchFamily="34" charset="0"/>
+                <a:ea typeface="Arial" pitchFamily="34" charset="-122"/>
+                <a:cs typeface="Arial" pitchFamily="34" charset="-120"/>
+              </a:rPr>
+              <a:t>همهٔ محصولات اطمینان «بالا» دارند — این پیش‌بینی‌ها برای برنامه‌ریزی تولید قابل‌اعتمادند.</a:t>
+            </a:r>
+            <a:endParaRPr lang="en-US" sz="1250" dirty="0"/>
+          </a:p>
+        </p:txBody>
+      </p:sp>
+      <p:sp>
+        <p:nvSpPr>
+          <p:cNvPr id="7" name="Shape 4"/>
+          <p:cNvSpPr/>
+          <p:nvPr/>
+        </p:nvSpPr>
+        <p:spPr>
+          <a:xfrm>
+            <a:off x="6263640" y="1691640"/>
+            <a:ext cx="5074920" cy="3886200"/>
+          </a:xfrm>
+          <a:prstGeom prst="roundRect">
+            <a:avLst>
+              <a:gd name="adj" fmla="val 2824"/>
+            </a:avLst>
+          </a:prstGeom>
+          <a:solidFill>
+            <a:srgbClr val="231815"/>
+          </a:solidFill>
+          <a:ln/>
+        </p:spPr>
+      </p:sp>
+      <p:sp>
+        <p:nvSpPr>
+          <p:cNvPr id="8" name="Text 5"/>
+          <p:cNvSpPr txBox="1"/>
+          <p:nvPr/>
+        </p:nvSpPr>
+        <p:spPr>
+          <a:xfrm>
+            <a:off x="6537960" y="1920240"/>
+            <a:ext cx="4526280" cy="457200"/>
+          </a:xfrm>
+          <a:prstGeom prst="rect">
+            <a:avLst/>
+          </a:prstGeom>
+          <a:noFill/>
+          <a:ln/>
+        </p:spPr>
+        <p:txBody>
+          <a:bodyPr wrap="square" lIns="0" tIns="0" rIns="0" bIns="0" rtlCol="0" anchor="ctr"/>
+          <a:lstStyle/>
+          <a:p>
+            <a:pPr algn="r" indent="0" marL="0">
+              <a:buNone/>
+            </a:pPr>
+            <a:r>
+              <a:rPr lang="en-US" sz="1600" b="1" dirty="0">
+                <a:solidFill>
+                  <a:srgbClr val="EF7D1F"/>
+                </a:solidFill>
+                <a:latin typeface="Arial" pitchFamily="34" charset="0"/>
+                <a:ea typeface="Arial" pitchFamily="34" charset="-122"/>
+                <a:cs typeface="Arial" pitchFamily="34" charset="-120"/>
+              </a:rPr>
+              <a:t>نمایندگان: افت و رشد همزمان</a:t>
+            </a:r>
+            <a:endParaRPr lang="en-US" sz="1600" dirty="0"/>
+          </a:p>
+        </p:txBody>
+      </p:sp>
+      <p:sp>
+        <p:nvSpPr>
+          <p:cNvPr id="9" name="Text 6"/>
+          <p:cNvSpPr txBox="1"/>
+          <p:nvPr/>
+        </p:nvSpPr>
+        <p:spPr>
+          <a:xfrm>
+            <a:off x="6537960" y="2423160"/>
+            <a:ext cx="4526280" cy="1188720"/>
+          </a:xfrm>
+          <a:prstGeom prst="rect">
+            <a:avLst/>
+          </a:prstGeom>
+          <a:noFill/>
+          <a:ln/>
+        </p:spPr>
+        <p:txBody>
+          <a:bodyPr wrap="square" lIns="0" tIns="0" rIns="0" bIns="0" rtlCol="0" anchor="ctr"/>
+          <a:lstStyle/>
+          <a:p>
+            <a:pPr algn="r" indent="0" marL="0">
+              <a:buNone/>
+            </a:pPr>
+            <a:r>
+              <a:rPr lang="en-US" sz="1300" dirty="0">
+                <a:solidFill>
+                  <a:srgbClr val="FFFFFF"/>
+                </a:solidFill>
+                <a:latin typeface="Arial" pitchFamily="34" charset="0"/>
+                <a:ea typeface="Arial" pitchFamily="34" charset="-122"/>
+                <a:cs typeface="Arial" pitchFamily="34" charset="-120"/>
+              </a:rPr>
+              <a:t>۵ نماینده در ۴ محصول مختلف کاملاً به صفر رسیده‌اند (نه فقط افت) — از جمله «شرکت شیمیایی بهداشت» که از نظر نام با سایر نمایندگان هم‌خوانی ندارد.</a:t>
+            </a:r>
+            <a:endParaRPr lang="en-US" sz="1300" dirty="0"/>
+          </a:p>
+        </p:txBody>
+      </p:sp>
+      <p:sp>
+        <p:nvSpPr>
+          <p:cNvPr id="10" name="Text 7"/>
+          <p:cNvSpPr txBox="1"/>
+          <p:nvPr/>
+        </p:nvSpPr>
+        <p:spPr>
+          <a:xfrm>
+            <a:off x="6537960" y="3657600"/>
+            <a:ext cx="4526280" cy="1097280"/>
+          </a:xfrm>
+          <a:prstGeom prst="rect">
+            <a:avLst/>
+          </a:prstGeom>
+          <a:noFill/>
+          <a:ln/>
+        </p:spPr>
+        <p:txBody>
+          <a:bodyPr wrap="square" lIns="0" tIns="0" rIns="0" bIns="0" rtlCol="0" anchor="ctr"/>
+          <a:lstStyle/>
+          <a:p>
+            <a:pPr algn="r" indent="0" marL="0">
+              <a:buNone/>
+            </a:pPr>
+            <a:r>
+              <a:rPr lang="en-US" sz="1300" dirty="0">
+                <a:solidFill>
+                  <a:srgbClr val="E8DFD2"/>
+                </a:solidFill>
+                <a:latin typeface="Arial" pitchFamily="34" charset="0"/>
+                <a:ea typeface="Arial" pitchFamily="34" charset="-122"/>
+                <a:cs typeface="Arial" pitchFamily="34" charset="-120"/>
+              </a:rPr>
+              <a:t>در همان زمان، تلابار و تخم مرغ تبدیلی ۸ نمایندهٔ تازه جذب کرده‌اند — بخشی از رشد آن‌ها از نمایندگان جدید است.</a:t>
+            </a:r>
+            <a:endParaRPr lang="en-US" sz="1300" dirty="0"/>
+          </a:p>
+        </p:txBody>
+      </p:sp>
+      <p:sp>
+        <p:nvSpPr>
+          <p:cNvPr id="11" name="Text 8"/>
+          <p:cNvSpPr txBox="1"/>
+          <p:nvPr/>
+        </p:nvSpPr>
+        <p:spPr>
+          <a:xfrm>
+            <a:off x="6537960" y="4800600"/>
+            <a:ext cx="4526280" cy="731520"/>
+          </a:xfrm>
+          <a:prstGeom prst="rect">
+            <a:avLst/>
+          </a:prstGeom>
+          <a:noFill/>
+          <a:ln/>
+        </p:spPr>
+        <p:txBody>
+          <a:bodyPr wrap="square" lIns="0" tIns="0" rIns="0" bIns="0" rtlCol="0" anchor="ctr"/>
+          <a:lstStyle/>
+          <a:p>
+            <a:pPr algn="r" indent="0" marL="0">
+              <a:buNone/>
+            </a:pPr>
+            <a:r>
+              <a:rPr lang="en-US" sz="1150" i="1" dirty="0">
+                <a:solidFill>
+                  <a:srgbClr val="C9BFAE"/>
+                </a:solidFill>
+                <a:latin typeface="Arial" pitchFamily="34" charset="0"/>
+                <a:ea typeface="Arial" pitchFamily="34" charset="-122"/>
+                <a:cs typeface="Arial" pitchFamily="34" charset="-120"/>
+              </a:rPr>
+              <a:t>از ۴۶ نماینده، ۳۳ نفر (۷۲٪) هر چهار محصول را همزمان می‌فروشند — افت یک نماینده‌ی بزرگ چند محصول را هم‌زمان می‌زند.</a:t>
+            </a:r>
+            <a:endParaRPr lang="en-US" sz="1150" dirty="0"/>
+          </a:p>
+        </p:txBody>
+      </p:sp>
+    </p:spTree>
+  </p:cSld>
+  <p:clrMapOvr>
+    <a:masterClrMapping/>
+  </p:clrMapOvr>
+</p:sld>
+</file>
+
+<file path=ppt/slides/slide7.xml><?xml version="1.0" encoding="utf-8"?>
+<p:sld xmlns:a="http://schemas.openxmlformats.org/drawingml/2006/main" xmlns:r="http://schemas.openxmlformats.org/officeDocument/2006/relationships" xmlns:p="http://schemas.openxmlformats.org/presentationml/2006/main">
+  <p:cSld name="Slide 7">
+    <p:spTree>
+      <p:nvGrpSpPr>
+        <p:cNvPr id="1" name=""/>
+        <p:cNvGrpSpPr/>
+        <p:nvPr/>
+      </p:nvGrpSpPr>
+      <p:grpSpPr>
+        <a:xfrm>
+          <a:off x="0" y="0"/>
+          <a:ext cx="0" cy="0"/>
+          <a:chOff x="0" y="0"/>
+          <a:chExt cx="0" cy="0"/>
+        </a:xfrm>
+      </p:grpSpPr>
+      <p:sp>
+        <p:nvSpPr>
+          <p:cNvPr id="2" name="Text 0"/>
+          <p:cNvSpPr/>
+          <p:nvPr>
+            <p:ph idx="100" type="title" hasCustomPrompt="1"/>
+          </p:nvPr>
+        </p:nvSpPr>
+        <p:spPr>
+          <a:xfrm>
+            <a:off x="640080" y="457200"/>
+            <a:ext cx="10881360" cy="822960"/>
+          </a:xfrm>
+          <a:prstGeom prst="rect">
+            <a:avLst/>
+          </a:prstGeom>
+          <a:noFill/>
+          <a:ln/>
+        </p:spPr>
+        <p:txBody>
+          <a:bodyPr wrap="square" lIns="0" tIns="0" rIns="0" bIns="0" rtlCol="0"/>
+          <a:lstStyle/>
+          <a:p>
+            <a:pPr algn="r" indent="0" marL="0">
+              <a:buNone/>
+            </a:pPr>
+            <a:r>
+              <a:rPr lang="en-US" sz="3000" b="1" dirty="0">
+                <a:solidFill>
+                  <a:srgbClr val="231815"/>
+                </a:solidFill>
+                <a:latin typeface="Arial" pitchFamily="34" charset="0"/>
+                <a:ea typeface="Arial" pitchFamily="34" charset="-122"/>
+                <a:cs typeface="Arial" pitchFamily="34" charset="-120"/>
+              </a:rPr>
               <a:t>فرصت‌ها و ریسک‌های جغرافیایی</a:t>
             </a:r>
             <a:endParaRPr lang="en-US" sz="3000" dirty="0"/>
@@ -5115,7 +6314,7 @@
       </p:sp>
       <p:graphicFrame>
         <p:nvGraphicFramePr>
-          <p:cNvPr id="7" name="Table 0"/>
+          <p:cNvPr id="8" name="Table 0"/>
           <p:cNvGraphicFramePr>
             <a:graphicFrameLocks noGrp="1"/>
           </p:cNvGraphicFramePr>
@@ -6208,7 +7407,7 @@
                 <a:ea typeface="Arial" pitchFamily="34" charset="-122"/>
                 <a:cs typeface="Arial" pitchFamily="34" charset="-120"/>
               </a:rPr>
-              <a:t>استان‌های بدون فروش</a:t>
+              <a:t>شکاف جمعیت در برابر فروش سرانه</a:t>
             </a:r>
             <a:endParaRPr lang="en-US" sz="1500" dirty="0"/>
           </a:p>
@@ -6222,8 +7421,8 @@
         </p:nvSpPr>
         <p:spPr>
           <a:xfrm>
-            <a:off x="7680960" y="2423160"/>
-            <a:ext cx="3474720" cy="1188720"/>
+            <a:off x="7680960" y="2377440"/>
+            <a:ext cx="3474720" cy="1051560"/>
           </a:xfrm>
           <a:prstGeom prst="rect">
             <a:avLst/>
@@ -6235,6 +7434,20 @@
           <a:bodyPr wrap="square" lIns="0" tIns="0" rIns="0" bIns="0" rtlCol="0" anchor="ctr"/>
           <a:lstStyle/>
           <a:p>
+            <a:pPr algn="r" indent="0" marL="0">
+              <a:buNone/>
+            </a:pPr>
+            <a:r>
+              <a:rPr lang="en-US" sz="1250" b="1" dirty="0">
+                <a:solidFill>
+                  <a:srgbClr val="EF7D1F"/>
+                </a:solidFill>
+                <a:latin typeface="Arial" pitchFamily="34" charset="0"/>
+                <a:ea typeface="Arial" pitchFamily="34" charset="-122"/>
+                <a:cs typeface="Arial" pitchFamily="34" charset="-120"/>
+              </a:rPr>
+              <a:t>تهران </a:t>
+            </a:r>
             <a:pPr algn="r" indent="0" marL="0">
               <a:buNone/>
             </a:pPr>
@@ -6247,7 +7460,7 @@
                 <a:ea typeface="Arial" pitchFamily="34" charset="-122"/>
                 <a:cs typeface="Arial" pitchFamily="34" charset="-120"/>
               </a:rPr>
-              <a:t>خراسان جنوبی، خراسان شمالی، سیستان و بلوچستان — در هیچ محصولی حتی یک فاکتور ثبت نشده است.</a:t>
+              <a:t>با ۱۳.۳ میلیون نفر پرجمعیت‌ترین استان است، اما فروش سرانهٔ آن ۶ برابر پایین‌تر از میانگین کشوری است.</a:t>
             </a:r>
             <a:endParaRPr lang="en-US" sz="1250" dirty="0"/>
           </a:p>
@@ -6261,8 +7474,8 @@
         </p:nvSpPr>
         <p:spPr>
           <a:xfrm>
-            <a:off x="7680960" y="3794760"/>
-            <a:ext cx="3474720" cy="1005840"/>
+            <a:off x="7680960" y="3474720"/>
+            <a:ext cx="3474720" cy="868680"/>
           </a:xfrm>
           <a:prstGeom prst="rect">
             <a:avLst/>
@@ -6278,7 +7491,7 @@
               <a:buNone/>
             </a:pPr>
             <a:r>
-              <a:rPr lang="en-US" sz="1300" dirty="0">
+              <a:rPr lang="en-US" sz="1200" dirty="0">
                 <a:solidFill>
                   <a:srgbClr val="E8DFD2"/>
                 </a:solidFill>
@@ -6286,9 +7499,9 @@
                 <a:ea typeface="Arial" pitchFamily="34" charset="-122"/>
                 <a:cs typeface="Arial" pitchFamily="34" charset="-120"/>
               </a:rPr>
-              <a:t>این سه استان جمعیت کمتری دارند و در اولویت پایین‌تری برای توسعه قرار می‌گیرند.</a:t>
+              <a:t>آذربایجان شرقی نیز وضعیت مشابهی دارد؛ در مقابل مازندران ۵ برابر میانگین کشوری فروش سرانه دارد.</a:t>
             </a:r>
-            <a:endParaRPr lang="en-US" sz="1300" dirty="0"/>
+            <a:endParaRPr lang="en-US" sz="1200" dirty="0"/>
           </a:p>
         </p:txBody>
       </p:sp>
@@ -6300,8 +7513,8 @@
         </p:nvSpPr>
         <p:spPr>
           <a:xfrm>
-            <a:off x="7680960" y="4846320"/>
-            <a:ext cx="3474720" cy="822960"/>
+            <a:off x="7680960" y="4434840"/>
+            <a:ext cx="3474720" cy="914400"/>
           </a:xfrm>
           <a:prstGeom prst="rect">
             <a:avLst/>
@@ -6317,9 +7530,48 @@
               <a:buNone/>
             </a:pPr>
             <a:r>
-              <a:rPr lang="en-US" sz="1200" i="1" dirty="0">
+              <a:rPr lang="en-US" sz="1100" i="1" dirty="0">
                 <a:solidFill>
-                  <a:srgbClr val="E8DFD2"/>
+                  <a:srgbClr val="C9BFAE"/>
+                </a:solidFill>
+                <a:latin typeface="Arial" pitchFamily="34" charset="0"/>
+                <a:ea typeface="Arial" pitchFamily="34" charset="-122"/>
+                <a:cs typeface="Arial" pitchFamily="34" charset="-120"/>
+              </a:rPr>
+              <a:t>سه استان (خراسان جنوبی، خراسان شمالی، سیستان و بلوچستان) هیچ فروشی ثبت‌شده ندارند؛ اولویت پایین‌تر دارند.</a:t>
+            </a:r>
+            <a:endParaRPr lang="en-US" sz="1100" dirty="0"/>
+          </a:p>
+        </p:txBody>
+      </p:sp>
+      <p:sp>
+        <p:nvSpPr>
+          <p:cNvPr id="9" name="Text 6"/>
+          <p:cNvSpPr txBox="1"/>
+          <p:nvPr/>
+        </p:nvSpPr>
+        <p:spPr>
+          <a:xfrm>
+            <a:off x="7680960" y="5349240"/>
+            <a:ext cx="3474720" cy="457200"/>
+          </a:xfrm>
+          <a:prstGeom prst="rect">
+            <a:avLst/>
+          </a:prstGeom>
+          <a:noFill/>
+          <a:ln/>
+        </p:spPr>
+        <p:txBody>
+          <a:bodyPr wrap="square" lIns="0" tIns="0" rIns="0" bIns="0" rtlCol="0" anchor="ctr"/>
+          <a:lstStyle/>
+          <a:p>
+            <a:pPr algn="r" indent="0" marL="0">
+              <a:buNone/>
+            </a:pPr>
+            <a:r>
+              <a:rPr lang="en-US" sz="1050" i="1" dirty="0">
+                <a:solidFill>
+                  <a:srgbClr val="C9BFAE"/>
                 </a:solidFill>
                 <a:latin typeface="Arial" pitchFamily="34" charset="0"/>
                 <a:ea typeface="Arial" pitchFamily="34" charset="-122"/>
@@ -6327,7 +7579,7 @@
               </a:rPr>
               <a:t>در همه محصولات، ۳ استان برتر ۴۰ تا ۴۷ درصد فروش را تشکیل می‌دهند.</a:t>
             </a:r>
-            <a:endParaRPr lang="en-US" sz="1200" dirty="0"/>
+            <a:endParaRPr lang="en-US" sz="1050" dirty="0"/>
           </a:p>
         </p:txBody>
       </p:sp>
@@ -6339,9 +7591,9 @@
 </p:sld>
 </file>
 
-<file path=ppt/slides/slide7.xml><?xml version="1.0" encoding="utf-8"?>
+<file path=ppt/slides/slide8.xml><?xml version="1.0" encoding="utf-8"?>
 <p:sld xmlns:a="http://schemas.openxmlformats.org/drawingml/2006/main" xmlns:r="http://schemas.openxmlformats.org/officeDocument/2006/relationships" xmlns:p="http://schemas.openxmlformats.org/presentationml/2006/main">
-  <p:cSld name="Slide 7">
+  <p:cSld name="Slide 8">
     <p:spTree>
       <p:nvGrpSpPr>
         <p:cNvPr id="1" name=""/>
@@ -7027,6 +8279,133 @@
                 <a:cs typeface="Arial" pitchFamily="34" charset="-120"/>
               </a:rPr>
               <a:t>روش ثبت «سفارش تولید» را بازبینی کنید</a:t>
+            </a:r>
+            <a:endParaRPr lang="en-US" sz="1400" dirty="0"/>
+          </a:p>
+        </p:txBody>
+      </p:sp>
+      <p:sp>
+        <p:nvSpPr>
+          <p:cNvPr id="23" name="Shape 21"/>
+          <p:cNvSpPr/>
+          <p:nvPr/>
+        </p:nvSpPr>
+        <p:spPr>
+          <a:xfrm>
+            <a:off x="6583680" y="4169664"/>
+            <a:ext cx="5166360" cy="960120"/>
+          </a:xfrm>
+          <a:prstGeom prst="roundRect">
+            <a:avLst>
+              <a:gd name="adj" fmla="val 9524"/>
+            </a:avLst>
+          </a:prstGeom>
+          <a:solidFill>
+            <a:srgbClr val="FFFFFF"/>
+          </a:solidFill>
+          <a:ln/>
+          <a:effectLst>
+            <a:outerShdw sx="100000" sy="100000" kx="0" ky="0" algn="bl" rotWithShape="0" blurRad="101600" dist="25400" dir="5400000">
+              <a:srgbClr val="4A3A2E">
+                <a:alpha val="14000"/>
+              </a:srgbClr>
+            </a:outerShdw>
+          </a:effectLst>
+        </p:spPr>
+      </p:sp>
+      <p:sp>
+        <p:nvSpPr>
+          <p:cNvPr id="24" name="Shape 22"/>
+          <p:cNvSpPr/>
+          <p:nvPr/>
+        </p:nvSpPr>
+        <p:spPr>
+          <a:xfrm>
+            <a:off x="10972800" y="4370832"/>
+            <a:ext cx="548640" cy="548640"/>
+          </a:xfrm>
+          <a:prstGeom prst="ellipse">
+            <a:avLst/>
+          </a:prstGeom>
+          <a:solidFill>
+            <a:srgbClr val="EF7D1F"/>
+          </a:solidFill>
+          <a:ln/>
+        </p:spPr>
+      </p:sp>
+      <p:sp>
+        <p:nvSpPr>
+          <p:cNvPr id="25" name="Text 23"/>
+          <p:cNvSpPr txBox="1"/>
+          <p:nvPr/>
+        </p:nvSpPr>
+        <p:spPr>
+          <a:xfrm>
+            <a:off x="10972800" y="4370832"/>
+            <a:ext cx="548640" cy="548640"/>
+          </a:xfrm>
+          <a:prstGeom prst="rect">
+            <a:avLst/>
+          </a:prstGeom>
+          <a:noFill/>
+          <a:ln/>
+        </p:spPr>
+        <p:txBody>
+          <a:bodyPr wrap="square" lIns="0" tIns="0" rIns="0" bIns="0" rtlCol="0" anchor="ctr"/>
+          <a:lstStyle/>
+          <a:p>
+            <a:pPr algn="ctr" indent="0" marL="0">
+              <a:buNone/>
+            </a:pPr>
+            <a:r>
+              <a:rPr lang="en-US" sz="1800" b="1" dirty="0">
+                <a:solidFill>
+                  <a:srgbClr val="FFFFFF"/>
+                </a:solidFill>
+                <a:latin typeface="Arial" pitchFamily="34" charset="0"/>
+                <a:ea typeface="Arial" pitchFamily="34" charset="-122"/>
+                <a:cs typeface="Arial" pitchFamily="34" charset="-120"/>
+              </a:rPr>
+              <a:t>6</a:t>
+            </a:r>
+            <a:endParaRPr lang="en-US" sz="1800" dirty="0"/>
+          </a:p>
+        </p:txBody>
+      </p:sp>
+      <p:sp>
+        <p:nvSpPr>
+          <p:cNvPr id="26" name="Text 24"/>
+          <p:cNvSpPr txBox="1"/>
+          <p:nvPr/>
+        </p:nvSpPr>
+        <p:spPr>
+          <a:xfrm>
+            <a:off x="6812280" y="4169664"/>
+            <a:ext cx="4114800" cy="960120"/>
+          </a:xfrm>
+          <a:prstGeom prst="rect">
+            <a:avLst/>
+          </a:prstGeom>
+          <a:noFill/>
+          <a:ln/>
+        </p:spPr>
+        <p:txBody>
+          <a:bodyPr wrap="square" lIns="0" tIns="0" rIns="0" bIns="0" rtlCol="0" anchor="ctr"/>
+          <a:lstStyle/>
+          <a:p>
+            <a:pPr algn="r" indent="0" marL="0">
+              <a:buNone/>
+            </a:pPr>
+            <a:r>
+              <a:rPr lang="en-US" sz="1400" b="1" dirty="0">
+                <a:solidFill>
+                  <a:srgbClr val="231815"/>
+                </a:solidFill>
+                <a:latin typeface="Arial" pitchFamily="34" charset="0"/>
+                <a:ea typeface="Arial" pitchFamily="34" charset="-122"/>
+                <a:cs typeface="Arial" pitchFamily="34" charset="-120"/>
+              </a:rPr>
+              <a:t>بازار تهران را نسبت به جمعیتش بازبینی کنید</a:t>
             </a:r>
             <a:endParaRPr lang="en-US" sz="1400" dirty="0"/>
           </a:p>

</xml_diff>

<commit_message>
Replace single-month growth bars with a 6-month indexed trend chart
Co-Authored-By: Claude Sonnet 5 <noreply@anthropic.com>
Claude-Session: https://claude.ai/code/session_014kMfh5CkRP5YXMJZm4gfqn
</commit_message>
<xml_diff>
--- a/telavang-sales-analysis.pptx
+++ b/telavang-sales-analysis.pptx
@@ -122,9 +122,7 @@
     <c:autoTitleDeleted val="1"/>
     <c:plotArea>
       <c:layout/>
-      <c:barChart>
-        <c:barDir val="col"/>
-        <c:grouping val="clustered"/>
+      <c:lineChart>
         <c:varyColors val="0"/>
         <c:ser>
           <c:idx val="0"/>
@@ -135,7 +133,133 @@
               <c:strCache>
                 <c:ptCount val="1"/>
                 <c:pt idx="0">
-                  <c:v>رشد (٪)</c:v>
+                  <c:v>تخم‌مرغ</c:v>
+                </c:pt>
+              </c:strCache>
+            </c:strRef>
+          </c:tx>
+          <c:spPr>
+            <a:solidFill>
+              <a:srgbClr val="1E2761"/>
+            </a:solidFill>
+            <a:ln w="31750" cap="flat">
+              <a:solidFill>
+                <a:srgbClr val="1E2761"/>
+              </a:solidFill>
+              <a:prstDash val="solid"/>
+              <a:round/>
+            </a:ln>
+            <a:effectLst/>
+          </c:spPr>
+          <c:invertIfNegative val="0"/>
+          <c:dLbls>
+            <c:numFmt formatCode="#,##0" sourceLinked="0"/>
+            <c:txPr>
+              <a:bodyPr/>
+              <a:lstStyle/>
+              <a:p>
+                <a:pPr>
+                  <a:defRPr b="0" i="0" strike="noStrike" sz="1200" u="none">
+                    <a:solidFill>
+                      <a:srgbClr val="000000"/>
+                    </a:solidFill>
+                    <a:latin typeface="Arial"/>
+                  </a:defRPr>
+                </a:pPr>
+              </a:p>
+            </c:txPr>
+            <c:showLegendKey val="0"/>
+            <c:showVal val="0"/>
+            <c:showCatName val="0"/>
+            <c:showSerName val="0"/>
+            <c:showPercent val="0"/>
+            <c:showBubbleSize val="0"/>
+            <c:showLeaderLines val="0"/>
+          </c:dLbls>
+          <c:marker>
+            <c:symbol val="circle"/>
+            <c:size val="6"/>
+            <c:spPr>
+              <a:solidFill>
+                <a:srgbClr val="1E2761"/>
+              </a:solidFill>
+              <a:ln w="9525" cap="flat">
+                <a:solidFill>
+                  <a:srgbClr val="1E2761"/>
+                </a:solidFill>
+                <a:prstDash val="solid"/>
+                <a:round/>
+              </a:ln>
+              <a:effectLst/>
+            </c:spPr>
+          </c:marker>
+          <c:cat>
+            <c:multiLvlStrRef>
+              <c:f>Sheet1!$A$2:$A$7</c:f>
+              <c:multiLvlStrCache>
+                <c:ptCount val="6"/>
+                <c:lvl>
+                  <c:pt idx="0">
+                    <c:v>فروردین</c:v>
+                  </c:pt>
+                  <c:pt idx="1">
+                    <c:v>اردیبهشت</c:v>
+                  </c:pt>
+                  <c:pt idx="2">
+                    <c:v>خرداد</c:v>
+                  </c:pt>
+                  <c:pt idx="3">
+                    <c:v>تیر</c:v>
+                  </c:pt>
+                  <c:pt idx="4">
+                    <c:v>مرداد</c:v>
+                  </c:pt>
+                  <c:pt idx="5">
+                    <c:v>شهریور</c:v>
+                  </c:pt>
+                </c:lvl>
+              </c:multiLvlStrCache>
+            </c:multiLvlStrRef>
+          </c:cat>
+          <c:val>
+            <c:numRef>
+              <c:f>Sheet1!$B$2:$B$7</c:f>
+              <c:numCache>
+                <c:formatCode>General</c:formatCode>
+                <c:ptCount val="6"/>
+                <c:pt idx="0">
+                  <c:v>100</c:v>
+                </c:pt>
+                <c:pt idx="1">
+                  <c:v>109</c:v>
+                </c:pt>
+                <c:pt idx="2">
+                  <c:v>95.2</c:v>
+                </c:pt>
+                <c:pt idx="3">
+                  <c:v>119.1</c:v>
+                </c:pt>
+                <c:pt idx="4">
+                  <c:v>116.4</c:v>
+                </c:pt>
+                <c:pt idx="5">
+                  <c:v>129.5</c:v>
+                </c:pt>
+              </c:numCache>
+            </c:numRef>
+          </c:val>
+          <c:smooth val="0"/>
+        </c:ser>
+        <c:ser>
+          <c:idx val="1"/>
+          <c:order val="1"/>
+          <c:tx>
+            <c:strRef>
+              <c:f>Sheet1!$C$1</c:f>
+              <c:strCache>
+                <c:ptCount val="1"/>
+                <c:pt idx="0">
+                  <c:v>تلابار</c:v>
                 </c:pt>
               </c:strCache>
             </c:strRef>
@@ -144,94 +268,80 @@
             <a:solidFill>
               <a:srgbClr val="EF7D1F"/>
             </a:solidFill>
+            <a:ln w="31750" cap="flat">
+              <a:solidFill>
+                <a:srgbClr val="EF7D1F"/>
+              </a:solidFill>
+              <a:prstDash val="solid"/>
+              <a:round/>
+            </a:ln>
             <a:effectLst/>
           </c:spPr>
           <c:invertIfNegative val="0"/>
           <c:dLbls>
-            <c:numFmt formatCode="0.0&quot;٪&quot;" sourceLinked="0"/>
+            <c:numFmt formatCode="#,##0" sourceLinked="0"/>
             <c:txPr>
               <a:bodyPr/>
               <a:lstStyle/>
               <a:p>
                 <a:pPr>
-                  <a:defRPr b="0" i="0" strike="noStrike" sz="1300" u="none">
+                  <a:defRPr b="0" i="0" strike="noStrike" sz="1200" u="none">
                     <a:solidFill>
-                      <a:srgbClr val="231815"/>
+                      <a:srgbClr val="000000"/>
                     </a:solidFill>
-                    <a:latin typeface="+mn-lt"/>
+                    <a:latin typeface="Arial"/>
                   </a:defRPr>
                 </a:pPr>
               </a:p>
             </c:txPr>
             <c:showLegendKey val="0"/>
-            <c:showVal val="1"/>
+            <c:showVal val="0"/>
             <c:showCatName val="0"/>
             <c:showSerName val="0"/>
             <c:showPercent val="0"/>
             <c:showBubbleSize val="0"/>
             <c:showLeaderLines val="0"/>
           </c:dLbls>
-          <c:dPt>
-            <c:idx val="0"/>
-            <c:invertIfNegative val="0"/>
-            <c:bubble3D val="0"/>
+          <c:marker>
+            <c:symbol val="circle"/>
+            <c:size val="6"/>
             <c:spPr>
               <a:solidFill>
                 <a:srgbClr val="EF7D1F"/>
               </a:solidFill>
+              <a:ln w="9525" cap="flat">
+                <a:solidFill>
+                  <a:srgbClr val="EF7D1F"/>
+                </a:solidFill>
+                <a:prstDash val="solid"/>
+                <a:round/>
+              </a:ln>
               <a:effectLst/>
             </c:spPr>
-          </c:dPt>
-          <c:dPt>
-            <c:idx val="1"/>
-            <c:invertIfNegative val="0"/>
-            <c:bubble3D val="0"/>
-            <c:spPr>
-              <a:solidFill>
-                <a:srgbClr val="EF7D1F"/>
-              </a:solidFill>
-              <a:effectLst/>
-            </c:spPr>
-          </c:dPt>
-          <c:dPt>
-            <c:idx val="2"/>
-            <c:invertIfNegative val="0"/>
-            <c:bubble3D val="0"/>
-            <c:spPr>
-              <a:solidFill>
-                <a:srgbClr val="EF7D1F"/>
-              </a:solidFill>
-              <a:effectLst/>
-            </c:spPr>
-          </c:dPt>
-          <c:dPt>
-            <c:idx val="3"/>
-            <c:invertIfNegative val="0"/>
-            <c:bubble3D val="0"/>
-            <c:spPr>
-              <a:solidFill>
-                <a:srgbClr val="C9442A"/>
-              </a:solidFill>
-              <a:effectLst/>
-            </c:spPr>
-          </c:dPt>
+          </c:marker>
           <c:cat>
             <c:multiLvlStrRef>
-              <c:f>Sheet1!$A$2:$A$5</c:f>
+              <c:f>Sheet1!$A$2:$A$7</c:f>
               <c:multiLvlStrCache>
-                <c:ptCount val="4"/>
+                <c:ptCount val="6"/>
                 <c:lvl>
                   <c:pt idx="0">
-                    <c:v>تخم‌مرغ</c:v>
+                    <c:v>فروردین</c:v>
                   </c:pt>
                   <c:pt idx="1">
-                    <c:v>تلابار</c:v>
+                    <c:v>اردیبهشت</c:v>
                   </c:pt>
                   <c:pt idx="2">
-                    <c:v>تخم مرغ تبدیلی</c:v>
+                    <c:v>خرداد</c:v>
                   </c:pt>
                   <c:pt idx="3">
-                    <c:v>تخم ماکیان</c:v>
+                    <c:v>تیر</c:v>
+                  </c:pt>
+                  <c:pt idx="4">
+                    <c:v>مرداد</c:v>
+                  </c:pt>
+                  <c:pt idx="5">
+                    <c:v>شهریور</c:v>
                   </c:pt>
                 </c:lvl>
               </c:multiLvlStrCache>
@@ -239,56 +349,314 @@
           </c:cat>
           <c:val>
             <c:numRef>
-              <c:f>Sheet1!$B$2:$B$5</c:f>
+              <c:f>Sheet1!$C$2:$C$7</c:f>
               <c:numCache>
                 <c:formatCode>General</c:formatCode>
-                <c:ptCount val="4"/>
+                <c:ptCount val="6"/>
                 <c:pt idx="0">
-                  <c:v>11.3</c:v>
+                  <c:v>100</c:v>
                 </c:pt>
                 <c:pt idx="1">
-                  <c:v>46.9</c:v>
+                  <c:v>146.1</c:v>
                 </c:pt>
                 <c:pt idx="2">
-                  <c:v>21.2</c:v>
+                  <c:v>121.5</c:v>
                 </c:pt>
                 <c:pt idx="3">
-                  <c:v>-5.4</c:v>
+                  <c:v>149.3</c:v>
+                </c:pt>
+                <c:pt idx="4">
+                  <c:v>166.3</c:v>
+                </c:pt>
+                <c:pt idx="5">
+                  <c:v>244.5</c:v>
                 </c:pt>
               </c:numCache>
             </c:numRef>
           </c:val>
+          <c:smooth val="0"/>
+        </c:ser>
+        <c:ser>
+          <c:idx val="2"/>
+          <c:order val="2"/>
+          <c:tx>
+            <c:strRef>
+              <c:f>Sheet1!$D$1</c:f>
+              <c:strCache>
+                <c:ptCount val="1"/>
+                <c:pt idx="0">
+                  <c:v>تخم مرغ تبدیلی</c:v>
+                </c:pt>
+              </c:strCache>
+            </c:strRef>
+          </c:tx>
+          <c:spPr>
+            <a:solidFill>
+              <a:srgbClr val="8A9A5B"/>
+            </a:solidFill>
+            <a:ln w="31750" cap="flat">
+              <a:solidFill>
+                <a:srgbClr val="8A9A5B"/>
+              </a:solidFill>
+              <a:prstDash val="solid"/>
+              <a:round/>
+            </a:ln>
+            <a:effectLst/>
+          </c:spPr>
+          <c:invertIfNegative val="0"/>
+          <c:dLbls>
+            <c:numFmt formatCode="#,##0" sourceLinked="0"/>
+            <c:txPr>
+              <a:bodyPr/>
+              <a:lstStyle/>
+              <a:p>
+                <a:pPr>
+                  <a:defRPr b="0" i="0" strike="noStrike" sz="1200" u="none">
+                    <a:solidFill>
+                      <a:srgbClr val="000000"/>
+                    </a:solidFill>
+                    <a:latin typeface="Arial"/>
+                  </a:defRPr>
+                </a:pPr>
+              </a:p>
+            </c:txPr>
+            <c:showLegendKey val="0"/>
+            <c:showVal val="0"/>
+            <c:showCatName val="0"/>
+            <c:showSerName val="0"/>
+            <c:showPercent val="0"/>
+            <c:showBubbleSize val="0"/>
+            <c:showLeaderLines val="0"/>
+          </c:dLbls>
+          <c:marker>
+            <c:symbol val="circle"/>
+            <c:size val="6"/>
+            <c:spPr>
+              <a:solidFill>
+                <a:srgbClr val="8A9A5B"/>
+              </a:solidFill>
+              <a:ln w="9525" cap="flat">
+                <a:solidFill>
+                  <a:srgbClr val="8A9A5B"/>
+                </a:solidFill>
+                <a:prstDash val="solid"/>
+                <a:round/>
+              </a:ln>
+              <a:effectLst/>
+            </c:spPr>
+          </c:marker>
+          <c:cat>
+            <c:multiLvlStrRef>
+              <c:f>Sheet1!$A$2:$A$7</c:f>
+              <c:multiLvlStrCache>
+                <c:ptCount val="6"/>
+                <c:lvl>
+                  <c:pt idx="0">
+                    <c:v>فروردین</c:v>
+                  </c:pt>
+                  <c:pt idx="1">
+                    <c:v>اردیبهشت</c:v>
+                  </c:pt>
+                  <c:pt idx="2">
+                    <c:v>خرداد</c:v>
+                  </c:pt>
+                  <c:pt idx="3">
+                    <c:v>تیر</c:v>
+                  </c:pt>
+                  <c:pt idx="4">
+                    <c:v>مرداد</c:v>
+                  </c:pt>
+                  <c:pt idx="5">
+                    <c:v>شهریور</c:v>
+                  </c:pt>
+                </c:lvl>
+              </c:multiLvlStrCache>
+            </c:multiLvlStrRef>
+          </c:cat>
+          <c:val>
+            <c:numRef>
+              <c:f>Sheet1!$D$2:$D$7</c:f>
+              <c:numCache>
+                <c:formatCode>General</c:formatCode>
+                <c:ptCount val="6"/>
+                <c:pt idx="0">
+                  <c:v>100</c:v>
+                </c:pt>
+                <c:pt idx="1">
+                  <c:v>128.6</c:v>
+                </c:pt>
+                <c:pt idx="2">
+                  <c:v>128.3</c:v>
+                </c:pt>
+                <c:pt idx="3">
+                  <c:v>146.7</c:v>
+                </c:pt>
+                <c:pt idx="4">
+                  <c:v>154.9</c:v>
+                </c:pt>
+                <c:pt idx="5">
+                  <c:v>187.8</c:v>
+                </c:pt>
+              </c:numCache>
+            </c:numRef>
+          </c:val>
+          <c:smooth val="0"/>
+        </c:ser>
+        <c:ser>
+          <c:idx val="3"/>
+          <c:order val="3"/>
+          <c:tx>
+            <c:strRef>
+              <c:f>Sheet1!$E$1</c:f>
+              <c:strCache>
+                <c:ptCount val="1"/>
+                <c:pt idx="0">
+                  <c:v>تخم ماکیان</c:v>
+                </c:pt>
+              </c:strCache>
+            </c:strRef>
+          </c:tx>
+          <c:spPr>
+            <a:solidFill>
+              <a:srgbClr val="C9442A"/>
+            </a:solidFill>
+            <a:ln w="31750" cap="flat">
+              <a:solidFill>
+                <a:srgbClr val="C9442A"/>
+              </a:solidFill>
+              <a:prstDash val="solid"/>
+              <a:round/>
+            </a:ln>
+            <a:effectLst/>
+          </c:spPr>
+          <c:invertIfNegative val="0"/>
+          <c:dLbls>
+            <c:numFmt formatCode="#,##0" sourceLinked="0"/>
+            <c:txPr>
+              <a:bodyPr/>
+              <a:lstStyle/>
+              <a:p>
+                <a:pPr>
+                  <a:defRPr b="0" i="0" strike="noStrike" sz="1200" u="none">
+                    <a:solidFill>
+                      <a:srgbClr val="000000"/>
+                    </a:solidFill>
+                    <a:latin typeface="Arial"/>
+                  </a:defRPr>
+                </a:pPr>
+              </a:p>
+            </c:txPr>
+            <c:showLegendKey val="0"/>
+            <c:showVal val="0"/>
+            <c:showCatName val="0"/>
+            <c:showSerName val="0"/>
+            <c:showPercent val="0"/>
+            <c:showBubbleSize val="0"/>
+            <c:showLeaderLines val="0"/>
+          </c:dLbls>
+          <c:marker>
+            <c:symbol val="circle"/>
+            <c:size val="6"/>
+            <c:spPr>
+              <a:solidFill>
+                <a:srgbClr val="C9442A"/>
+              </a:solidFill>
+              <a:ln w="9525" cap="flat">
+                <a:solidFill>
+                  <a:srgbClr val="C9442A"/>
+                </a:solidFill>
+                <a:prstDash val="solid"/>
+                <a:round/>
+              </a:ln>
+              <a:effectLst/>
+            </c:spPr>
+          </c:marker>
+          <c:cat>
+            <c:multiLvlStrRef>
+              <c:f>Sheet1!$A$2:$A$7</c:f>
+              <c:multiLvlStrCache>
+                <c:ptCount val="6"/>
+                <c:lvl>
+                  <c:pt idx="0">
+                    <c:v>فروردین</c:v>
+                  </c:pt>
+                  <c:pt idx="1">
+                    <c:v>اردیبهشت</c:v>
+                  </c:pt>
+                  <c:pt idx="2">
+                    <c:v>خرداد</c:v>
+                  </c:pt>
+                  <c:pt idx="3">
+                    <c:v>تیر</c:v>
+                  </c:pt>
+                  <c:pt idx="4">
+                    <c:v>مرداد</c:v>
+                  </c:pt>
+                  <c:pt idx="5">
+                    <c:v>شهریور</c:v>
+                  </c:pt>
+                </c:lvl>
+              </c:multiLvlStrCache>
+            </c:multiLvlStrRef>
+          </c:cat>
+          <c:val>
+            <c:numRef>
+              <c:f>Sheet1!$E$2:$E$7</c:f>
+              <c:numCache>
+                <c:formatCode>General</c:formatCode>
+                <c:ptCount val="6"/>
+                <c:pt idx="0">
+                  <c:v>100</c:v>
+                </c:pt>
+                <c:pt idx="1">
+                  <c:v>116.3</c:v>
+                </c:pt>
+                <c:pt idx="2">
+                  <c:v>111.4</c:v>
+                </c:pt>
+                <c:pt idx="3">
+                  <c:v>127.4</c:v>
+                </c:pt>
+                <c:pt idx="4">
+                  <c:v>146.9</c:v>
+                </c:pt>
+                <c:pt idx="5">
+                  <c:v>138.9</c:v>
+                </c:pt>
+              </c:numCache>
+            </c:numRef>
+          </c:val>
+          <c:smooth val="0"/>
         </c:ser>
         <c:dLbls>
-          <c:numFmt formatCode="0.0&quot;٪&quot;" sourceLinked="0"/>
+          <c:numFmt formatCode="#,##0" sourceLinked="0"/>
           <c:txPr>
             <a:bodyPr/>
             <a:lstStyle/>
             <a:p>
               <a:pPr>
-                <a:defRPr b="0" i="0" strike="noStrike" sz="1300" u="none">
+                <a:defRPr b="0" i="0" strike="noStrike" sz="1200" u="none">
                   <a:solidFill>
-                    <a:srgbClr val="231815"/>
+                    <a:srgbClr val="000000"/>
                   </a:solidFill>
-                  <a:latin typeface="+mn-lt"/>
+                  <a:latin typeface="Arial"/>
                 </a:defRPr>
               </a:pPr>
             </a:p>
           </c:txPr>
           <c:showLegendKey val="0"/>
-          <c:showVal val="1"/>
+          <c:showVal val="0"/>
           <c:showCatName val="0"/>
           <c:showSerName val="0"/>
           <c:showPercent val="0"/>
           <c:showBubbleSize val="0"/>
           <c:showLeaderLines val="0"/>
         </c:dLbls>
-        <c:gapWidth val="150"/>
-        <c:overlap val="0"/>
+        <c:marker val="1"/>
         <c:axId val="2094734554"/>
         <c:axId val="2094734552"/>
         <c:axId val="2094734556"/>
-      </c:barChart>
+      </c:lineChart>
       <c:catAx>
         <c:axId val="2094734554"/>
         <c:scaling>
@@ -314,7 +682,7 @@
           <a:lstStyle/>
           <a:p>
             <a:pPr>
-              <a:defRPr sz="1300" b="0" i="0" u="none" strike="noStrike">
+              <a:defRPr sz="1250" b="0" i="0" u="none" strike="noStrike">
                 <a:solidFill>
                   <a:srgbClr val="231815"/>
                 </a:solidFill>
@@ -348,6 +716,35 @@
             </a:ln>
           </c:spPr>
         </c:majorGridlines>
+        <c:title>
+          <c:tx>
+            <c:rich>
+              <a:bodyPr/>
+              <a:lstStyle/>
+              <a:p>
+                <a:pPr>
+                  <a:defRPr b="0" i="0" u="none" strike="noStrike">
+                    <a:solidFill>
+                      <a:srgbClr val="4A3A2E"/>
+                    </a:solidFill>
+                    <a:latin typeface="+mn-lt"/>
+                  </a:defRPr>
+                </a:pPr>
+                <a:r>
+                  <a:rPr b="0" i="0" u="none" strike="noStrike">
+                    <a:solidFill>
+                      <a:srgbClr val="4A3A2E"/>
+                    </a:solidFill>
+                    <a:latin typeface="+mn-lt"/>
+                  </a:rPr>
+                  <a:t>شاخص</a:t>
+                </a:r>
+              </a:p>
+            </c:rich>
+          </c:tx>
+          <c:layout/>
+          <c:overlay val="0"/>
+        </c:title>
         <c:numFmt formatCode="General" sourceLinked="0"/>
         <c:majorTickMark val="out"/>
         <c:minorTickMark val="none"/>
@@ -386,6 +783,26 @@
         <a:effectLst/>
       </c:spPr>
     </c:plotArea>
+    <c:legend>
+      <c:legendPos val="b"/>
+      <c:overlay val="0"/>
+      <c:txPr>
+        <a:bodyPr/>
+        <a:lstStyle/>
+        <a:p>
+          <a:pPr>
+            <a:defRPr sz="1200">
+              <a:solidFill>
+                <a:srgbClr val="231815"/>
+              </a:solidFill>
+              <a:latin typeface="+mn-lt"/>
+              <a:cs typeface="+mn-lt"/>
+            </a:defRPr>
+          </a:pPr>
+          <a:endParaRPr lang="en-US"/>
+        </a:p>
+      </c:txPr>
+    </c:legend>
     <c:plotVisOnly val="1"/>
     <c:dispBlanksAs val="span"/>
   </c:chart>
@@ -3056,7 +3473,7 @@
                 <a:ea typeface="Arial" pitchFamily="34" charset="-122"/>
                 <a:cs typeface="Arial" pitchFamily="34" charset="-120"/>
               </a:rPr>
-              <a:t>مقایسهٔ نرخ رشد محصولات</a:t>
+              <a:t>روند ۶ ماههٔ رشد محصولات (شاخص، فروردین = ۱۰۰)</a:t>
             </a:r>
             <a:endParaRPr lang="en-US" sz="3000" dirty="0"/>
           </a:p>
@@ -3069,8 +3486,8 @@
           <p:nvPr/>
         </p:nvGraphicFramePr>
         <p:xfrm>
-          <a:off x="822960" y="1600200"/>
-          <a:ext cx="10515600" cy="4480560"/>
+          <a:off x="822960" y="1508760"/>
+          <a:ext cx="10515600" cy="3794760"/>
         </p:xfrm>
         <a:graphic xmlns:a="http://schemas.openxmlformats.org/drawingml/2006/main">
           <a:graphicData uri="http://schemas.openxmlformats.org/drawingml/2006/chart">
@@ -3086,8 +3503,8 @@
         </p:nvSpPr>
         <p:spPr>
           <a:xfrm>
-            <a:off x="822960" y="6172200"/>
-            <a:ext cx="10515600" cy="548640"/>
+            <a:off x="822960" y="5440680"/>
+            <a:ext cx="10515600" cy="502920"/>
           </a:xfrm>
           <a:prstGeom prst="rect">
             <a:avLst/>
@@ -3103,7 +3520,74 @@
               <a:buNone/>
             </a:pPr>
             <a:r>
-              <a:rPr lang="en-US" sz="1150" b="1" i="1" dirty="0">
+              <a:rPr lang="en-US" sz="1200" dirty="0">
+                <a:solidFill>
+                  <a:srgbClr val="231815"/>
+                </a:solidFill>
+                <a:latin typeface="Arial" pitchFamily="34" charset="0"/>
+                <a:ea typeface="Arial" pitchFamily="34" charset="-122"/>
+                <a:cs typeface="Arial" pitchFamily="34" charset="-120"/>
+              </a:rPr>
+              <a:t>هیچ‌کدام روند یکنواخت ندارند — هر چهار محصول حداقل یک‌بار در این ۶ ماه افت داشته‌اند. </a:t>
+            </a:r>
+            <a:pPr algn="r" indent="0" marL="0">
+              <a:buNone/>
+            </a:pPr>
+            <a:r>
+              <a:rPr lang="en-US" sz="1200" b="1" dirty="0">
+                <a:solidFill>
+                  <a:srgbClr val="231815"/>
+                </a:solidFill>
+                <a:latin typeface="Arial" pitchFamily="34" charset="0"/>
+                <a:ea typeface="Arial" pitchFamily="34" charset="-122"/>
+                <a:cs typeface="Arial" pitchFamily="34" charset="-120"/>
+              </a:rPr>
+              <a:t>جهش ۴۶٫۹٪ تلابار در شهریور تکرار یک الگوی قبلی است (اردیبهشت هم +۴۶٫۱٪ داشت)، </a:t>
+            </a:r>
+            <a:pPr algn="r" indent="0" marL="0">
+              <a:buNone/>
+            </a:pPr>
+            <a:r>
+              <a:rPr lang="en-US" sz="1200" dirty="0">
+                <a:solidFill>
+                  <a:srgbClr val="231815"/>
+                </a:solidFill>
+                <a:latin typeface="Arial" pitchFamily="34" charset="0"/>
+                <a:ea typeface="Arial" pitchFamily="34" charset="-122"/>
+                <a:cs typeface="Arial" pitchFamily="34" charset="-120"/>
+              </a:rPr>
+              <a:t>نه یک اتفاق تازه؛ افت تخم ماکیان هم سومین افتش در ۶ ماه است.</a:t>
+            </a:r>
+            <a:endParaRPr lang="en-US" sz="1200" dirty="0"/>
+          </a:p>
+        </p:txBody>
+      </p:sp>
+      <p:sp>
+        <p:nvSpPr>
+          <p:cNvPr id="5" name="Text 2"/>
+          <p:cNvSpPr txBox="1"/>
+          <p:nvPr/>
+        </p:nvSpPr>
+        <p:spPr>
+          <a:xfrm>
+            <a:off x="822960" y="5989320"/>
+            <a:ext cx="10515600" cy="457200"/>
+          </a:xfrm>
+          <a:prstGeom prst="rect">
+            <a:avLst/>
+          </a:prstGeom>
+          <a:noFill/>
+          <a:ln/>
+        </p:spPr>
+        <p:txBody>
+          <a:bodyPr wrap="square" lIns="0" tIns="0" rIns="0" bIns="0" rtlCol="0" anchor="ctr"/>
+          <a:lstStyle/>
+          <a:p>
+            <a:pPr algn="r" indent="0" marL="0">
+              <a:buNone/>
+            </a:pPr>
+            <a:r>
+              <a:rPr lang="en-US" sz="1100" b="1" i="1" dirty="0">
                 <a:solidFill>
                   <a:srgbClr val="4A3A2E"/>
                 </a:solidFill>
@@ -3117,7 +3601,7 @@
               <a:buNone/>
             </a:pPr>
             <a:r>
-              <a:rPr lang="en-US" sz="1150" i="1" dirty="0">
+              <a:rPr lang="en-US" sz="1100" i="1" dirty="0">
                 <a:solidFill>
                   <a:srgbClr val="4A3A2E"/>
                 </a:solidFill>
@@ -3125,9 +3609,9 @@
                 <a:ea typeface="Arial" pitchFamily="34" charset="-122"/>
                 <a:cs typeface="Arial" pitchFamily="34" charset="-120"/>
               </a:rPr>
-              <a:t>(بزرگ‌ترین کانال، خارج از این نمودار) این ماه ۸٫۶٪− افت کرده، اما نسبت به مدت مشابه سال قبل ۶۳٫۴٪+ رشد داشته — افت ماهانه در کنار روند بلندمدت صعودی باید دیده شود.</a:t>
+              <a:t>(بزرگ‌ترین کانال، خارج از این نمودار به‌دلیل مقیاس) این ماه ۸٫۶٪− افت کرده، اما نسبت به سال قبل ۶۳٫۴٪+ رشد داشته.</a:t>
             </a:r>
-            <a:endParaRPr lang="en-US" sz="1150" dirty="0"/>
+            <a:endParaRPr lang="en-US" sz="1100" dirty="0"/>
           </a:p>
         </p:txBody>
       </p:sp>

</xml_diff>